<commit_message>
final cleanup before presentation
</commit_message>
<xml_diff>
--- a/Web Crawler Powerpoint.pptx
+++ b/Web Crawler Powerpoint.pptx
@@ -5,7 +5,7 @@
     <p:sldMasterId id="2147483648" r:id="rId1"/>
   </p:sldMasterIdLst>
   <p:notesMasterIdLst>
-    <p:notesMasterId r:id="rId16"/>
+    <p:notesMasterId r:id="rId15"/>
   </p:notesMasterIdLst>
   <p:sldIdLst>
     <p:sldId id="256" r:id="rId2"/>
@@ -15,13 +15,12 @@
     <p:sldId id="260" r:id="rId6"/>
     <p:sldId id="261" r:id="rId7"/>
     <p:sldId id="262" r:id="rId8"/>
-    <p:sldId id="263" r:id="rId9"/>
-    <p:sldId id="264" r:id="rId10"/>
-    <p:sldId id="265" r:id="rId11"/>
-    <p:sldId id="266" r:id="rId12"/>
-    <p:sldId id="267" r:id="rId13"/>
-    <p:sldId id="268" r:id="rId14"/>
-    <p:sldId id="269" r:id="rId15"/>
+    <p:sldId id="264" r:id="rId9"/>
+    <p:sldId id="265" r:id="rId10"/>
+    <p:sldId id="266" r:id="rId11"/>
+    <p:sldId id="267" r:id="rId12"/>
+    <p:sldId id="268" r:id="rId13"/>
+    <p:sldId id="269" r:id="rId14"/>
   </p:sldIdLst>
   <p:sldSz cx="12192000" cy="6858000"/>
   <p:notesSz cx="6858000" cy="12192000"/>
@@ -661,90 +660,6 @@
             <a:fld id="{F7021451-1387-4CA6-816F-3879F97B5CBC}" type="slidenum">
               <a:rPr lang="en-US"/>
               <a:t>13</a:t>
-            </a:fld>
-            <a:endParaRPr lang="en-US"/>
-          </a:p>
-        </p:txBody>
-      </p:sp>
-    </p:spTree>
-    <p:extLst>
-      <p:ext uri="{BB962C8B-B14F-4D97-AF65-F5344CB8AC3E}">
-        <p14:creationId xmlns:p14="http://schemas.microsoft.com/office/powerpoint/2010/main" val="1024086991"/>
-      </p:ext>
-    </p:extLst>
-  </p:cSld>
-  <p:clrMapOvr>
-    <a:masterClrMapping/>
-  </p:clrMapOvr>
-</p:notes>
-</file>
-
-<file path=ppt/notesSlides/notesSlide14.xml><?xml version="1.0" encoding="utf-8"?>
-<p:notes xmlns:a="http://schemas.openxmlformats.org/drawingml/2006/main" xmlns:r="http://schemas.openxmlformats.org/officeDocument/2006/relationships" xmlns:p="http://schemas.openxmlformats.org/presentationml/2006/main">
-  <p:cSld>
-    <p:spTree>
-      <p:nvGrpSpPr>
-        <p:cNvPr id="1" name=""/>
-        <p:cNvGrpSpPr/>
-        <p:nvPr/>
-      </p:nvGrpSpPr>
-      <p:grpSpPr>
-        <a:xfrm>
-          <a:off x="0" y="0"/>
-          <a:ext cx="0" cy="0"/>
-          <a:chOff x="0" y="0"/>
-          <a:chExt cx="0" cy="0"/>
-        </a:xfrm>
-      </p:grpSpPr>
-      <p:sp>
-        <p:nvSpPr>
-          <p:cNvPr id="2" name="Slide Image Placeholder 1"/>
-          <p:cNvSpPr>
-            <a:spLocks noGrp="1" noRot="1" noChangeAspect="1"/>
-          </p:cNvSpPr>
-          <p:nvPr>
-            <p:ph type="sldImg"/>
-          </p:nvPr>
-        </p:nvSpPr>
-        <p:spPr/>
-      </p:sp>
-      <p:sp>
-        <p:nvSpPr>
-          <p:cNvPr id="3" name="Notes Placeholder 2"/>
-          <p:cNvSpPr>
-            <a:spLocks noGrp="1"/>
-          </p:cNvSpPr>
-          <p:nvPr>
-            <p:ph type="body" idx="1"/>
-          </p:nvPr>
-        </p:nvSpPr>
-        <p:spPr/>
-        <p:txBody>
-          <a:bodyPr/>
-          <a:lstStyle/>
-          <a:p>
-            <a:endParaRPr lang="en-US" dirty="0"/>
-          </a:p>
-        </p:txBody>
-      </p:sp>
-      <p:sp>
-        <p:nvSpPr>
-          <p:cNvPr id="4" name="Slide Number Placeholder 3"/>
-          <p:cNvSpPr>
-            <a:spLocks noGrp="1"/>
-          </p:cNvSpPr>
-          <p:nvPr>
-            <p:ph type="sldNum" sz="quarter" idx="10"/>
-          </p:nvPr>
-        </p:nvSpPr>
-        <p:spPr/>
-        <p:txBody>
-          <a:bodyPr/>
-          <a:lstStyle/>
-          <a:p>
-            <a:fld id="{F7021451-1387-4CA6-816F-3879F97B5CBC}" type="slidenum">
-              <a:rPr lang="en-US"/>
-              <a:t>14</a:t>
             </a:fld>
             <a:endParaRPr lang="en-US"/>
           </a:p>
@@ -2439,1201 +2354,6 @@
 
 <file path=ppt/slides/slide10.xml><?xml version="1.0" encoding="utf-8"?>
 <p:sld xmlns:a="http://schemas.openxmlformats.org/drawingml/2006/main" xmlns:r="http://schemas.openxmlformats.org/officeDocument/2006/relationships" xmlns:p="http://schemas.openxmlformats.org/presentationml/2006/main">
-  <p:cSld name="Slide 10">
-    <p:bg>
-      <p:bgPr>
-        <a:solidFill>
-          <a:srgbClr val="FFFFFF"/>
-        </a:solidFill>
-        <a:effectLst/>
-      </p:bgPr>
-    </p:bg>
-    <p:spTree>
-      <p:nvGrpSpPr>
-        <p:cNvPr id="1" name=""/>
-        <p:cNvGrpSpPr/>
-        <p:nvPr/>
-      </p:nvGrpSpPr>
-      <p:grpSpPr>
-        <a:xfrm>
-          <a:off x="0" y="0"/>
-          <a:ext cx="0" cy="0"/>
-          <a:chOff x="0" y="0"/>
-          <a:chExt cx="0" cy="0"/>
-        </a:xfrm>
-      </p:grpSpPr>
-      <p:sp>
-        <p:nvSpPr>
-          <p:cNvPr id="2" name="Shape 0"/>
-          <p:cNvSpPr/>
-          <p:nvPr/>
-        </p:nvSpPr>
-        <p:spPr>
-          <a:xfrm>
-            <a:off x="457200" y="502920"/>
-            <a:ext cx="164592" cy="164592"/>
-          </a:xfrm>
-          <a:prstGeom prst="ellipse">
-            <a:avLst/>
-          </a:prstGeom>
-          <a:solidFill>
-            <a:srgbClr val="14B8A6"/>
-          </a:solidFill>
-          <a:ln/>
-        </p:spPr>
-        <p:txBody>
-          <a:bodyPr/>
-          <a:lstStyle/>
-          <a:p>
-            <a:endParaRPr lang="en-US"/>
-          </a:p>
-        </p:txBody>
-      </p:sp>
-      <p:sp>
-        <p:nvSpPr>
-          <p:cNvPr id="3" name="Text 1"/>
-          <p:cNvSpPr/>
-          <p:nvPr/>
-        </p:nvSpPr>
-        <p:spPr>
-          <a:xfrm>
-            <a:off x="713232" y="411480"/>
-            <a:ext cx="5486400" cy="320040"/>
-          </a:xfrm>
-          <a:prstGeom prst="rect">
-            <a:avLst/>
-          </a:prstGeom>
-          <a:noFill/>
-          <a:ln/>
-        </p:spPr>
-        <p:txBody>
-          <a:bodyPr wrap="square" lIns="0" tIns="0" rIns="0" bIns="0" rtlCol="0" anchor="ctr"/>
-          <a:lstStyle/>
-          <a:p>
-            <a:pPr marL="0" indent="0">
-              <a:buNone/>
-            </a:pPr>
-            <a:r>
-              <a:rPr lang="en-US" sz="1000" b="1" kern="0" spc="400" dirty="0">
-                <a:solidFill>
-                  <a:srgbClr val="64748B"/>
-                </a:solidFill>
-                <a:latin typeface="Calibri" pitchFamily="34" charset="0"/>
-                <a:ea typeface="Calibri" pitchFamily="34" charset="-122"/>
-                <a:cs typeface="Calibri" pitchFamily="34" charset="-120"/>
-              </a:rPr>
-              <a:t>PAGEHARVESTER  ·  GROUP 7</a:t>
-            </a:r>
-            <a:endParaRPr lang="en-US" sz="1000" dirty="0"/>
-          </a:p>
-        </p:txBody>
-      </p:sp>
-      <p:sp>
-        <p:nvSpPr>
-          <p:cNvPr id="4" name="Text 2"/>
-          <p:cNvSpPr/>
-          <p:nvPr/>
-        </p:nvSpPr>
-        <p:spPr>
-          <a:xfrm>
-            <a:off x="457200" y="822960"/>
-            <a:ext cx="11247120" cy="731520"/>
-          </a:xfrm>
-          <a:prstGeom prst="rect">
-            <a:avLst/>
-          </a:prstGeom>
-          <a:noFill/>
-          <a:ln/>
-        </p:spPr>
-        <p:txBody>
-          <a:bodyPr wrap="square" lIns="0" tIns="0" rIns="0" bIns="0" rtlCol="0" anchor="ctr"/>
-          <a:lstStyle/>
-          <a:p>
-            <a:pPr marL="0" indent="0">
-              <a:buNone/>
-            </a:pPr>
-            <a:r>
-              <a:rPr lang="en-US" sz="3200" b="1" dirty="0">
-                <a:solidFill>
-                  <a:srgbClr val="0F172A"/>
-                </a:solidFill>
-                <a:latin typeface="Georgia" pitchFamily="34" charset="0"/>
-                <a:ea typeface="Georgia" pitchFamily="34" charset="-122"/>
-                <a:cs typeface="Georgia" pitchFamily="34" charset="-120"/>
-              </a:rPr>
-              <a:t>Q3 — Implementing an Efficient Crawler</a:t>
-            </a:r>
-            <a:endParaRPr lang="en-US" sz="3200" dirty="0"/>
-          </a:p>
-        </p:txBody>
-      </p:sp>
-      <p:sp>
-        <p:nvSpPr>
-          <p:cNvPr id="5" name="Text 3"/>
-          <p:cNvSpPr/>
-          <p:nvPr/>
-        </p:nvSpPr>
-        <p:spPr>
-          <a:xfrm>
-            <a:off x="11247120" y="6446520"/>
-            <a:ext cx="731520" cy="274320"/>
-          </a:xfrm>
-          <a:prstGeom prst="rect">
-            <a:avLst/>
-          </a:prstGeom>
-          <a:noFill/>
-          <a:ln/>
-        </p:spPr>
-        <p:txBody>
-          <a:bodyPr wrap="square" lIns="0" tIns="0" rIns="0" bIns="0" rtlCol="0" anchor="ctr"/>
-          <a:lstStyle/>
-          <a:p>
-            <a:pPr marL="0" indent="0" algn="r">
-              <a:buNone/>
-            </a:pPr>
-            <a:r>
-              <a:rPr lang="en-US" sz="900" dirty="0">
-                <a:solidFill>
-                  <a:srgbClr val="94A3B8"/>
-                </a:solidFill>
-                <a:latin typeface="Calibri" pitchFamily="34" charset="0"/>
-                <a:ea typeface="Calibri" pitchFamily="34" charset="-122"/>
-                <a:cs typeface="Calibri" pitchFamily="34" charset="-120"/>
-              </a:rPr>
-              <a:t>10 / 14</a:t>
-            </a:r>
-            <a:endParaRPr lang="en-US" sz="900" dirty="0"/>
-          </a:p>
-        </p:txBody>
-      </p:sp>
-      <p:sp>
-        <p:nvSpPr>
-          <p:cNvPr id="6" name="Text 4"/>
-          <p:cNvSpPr/>
-          <p:nvPr/>
-        </p:nvSpPr>
-        <p:spPr>
-          <a:xfrm>
-            <a:off x="457200" y="6446520"/>
-            <a:ext cx="3657600" cy="274320"/>
-          </a:xfrm>
-          <a:prstGeom prst="rect">
-            <a:avLst/>
-          </a:prstGeom>
-          <a:noFill/>
-          <a:ln/>
-        </p:spPr>
-        <p:txBody>
-          <a:bodyPr wrap="square" lIns="0" tIns="0" rIns="0" bIns="0" rtlCol="0" anchor="ctr"/>
-          <a:lstStyle/>
-          <a:p>
-            <a:pPr marL="0" indent="0">
-              <a:buNone/>
-            </a:pPr>
-            <a:r>
-              <a:rPr lang="en-US" sz="900" dirty="0">
-                <a:solidFill>
-                  <a:srgbClr val="94A3B8"/>
-                </a:solidFill>
-                <a:latin typeface="Calibri" pitchFamily="34" charset="0"/>
-                <a:ea typeface="Calibri" pitchFamily="34" charset="-122"/>
-                <a:cs typeface="Calibri" pitchFamily="34" charset="-120"/>
-              </a:rPr>
-              <a:t>CS 494/493</a:t>
-            </a:r>
-            <a:endParaRPr lang="en-US" sz="900" dirty="0"/>
-          </a:p>
-        </p:txBody>
-      </p:sp>
-      <p:sp>
-        <p:nvSpPr>
-          <p:cNvPr id="7" name="Text 5"/>
-          <p:cNvSpPr/>
-          <p:nvPr/>
-        </p:nvSpPr>
-        <p:spPr>
-          <a:xfrm>
-            <a:off x="457200" y="1554480"/>
-            <a:ext cx="10972800" cy="365760"/>
-          </a:xfrm>
-          <a:prstGeom prst="rect">
-            <a:avLst/>
-          </a:prstGeom>
-          <a:noFill/>
-          <a:ln/>
-        </p:spPr>
-        <p:txBody>
-          <a:bodyPr wrap="square" lIns="0" tIns="0" rIns="0" bIns="0" rtlCol="0" anchor="ctr"/>
-          <a:lstStyle/>
-          <a:p>
-            <a:pPr marL="0" indent="0">
-              <a:buNone/>
-            </a:pPr>
-            <a:r>
-              <a:rPr lang="en-US" sz="1300" i="1" dirty="0">
-                <a:solidFill>
-                  <a:srgbClr val="64748B"/>
-                </a:solidFill>
-                <a:latin typeface="Calibri" pitchFamily="34" charset="0"/>
-                <a:ea typeface="Calibri" pitchFamily="34" charset="-122"/>
-                <a:cs typeface="Calibri" pitchFamily="34" charset="-120"/>
-              </a:rPr>
-              <a:t>Efficiency items in PageHarvester — cutting wasted requests, parses, and disk operations.</a:t>
-            </a:r>
-            <a:endParaRPr lang="en-US" sz="1300" dirty="0"/>
-          </a:p>
-        </p:txBody>
-      </p:sp>
-      <p:sp>
-        <p:nvSpPr>
-          <p:cNvPr id="8" name="Shape 6"/>
-          <p:cNvSpPr/>
-          <p:nvPr/>
-        </p:nvSpPr>
-        <p:spPr>
-          <a:xfrm>
-            <a:off x="444856" y="2103120"/>
-            <a:ext cx="3657600" cy="1828800"/>
-          </a:xfrm>
-          <a:prstGeom prst="rect">
-            <a:avLst/>
-          </a:prstGeom>
-          <a:solidFill>
-            <a:srgbClr val="FFFFFF"/>
-          </a:solidFill>
-          <a:ln w="12700">
-            <a:solidFill>
-              <a:srgbClr val="E2E8F0"/>
-            </a:solidFill>
-            <a:prstDash val="solid"/>
-          </a:ln>
-          <a:effectLst>
-            <a:outerShdw blurRad="101600" dist="25400" dir="5400000" algn="bl" rotWithShape="0">
-              <a:srgbClr val="0F172A">
-                <a:alpha val="8000"/>
-              </a:srgbClr>
-            </a:outerShdw>
-          </a:effectLst>
-        </p:spPr>
-        <p:txBody>
-          <a:bodyPr/>
-          <a:lstStyle/>
-          <a:p>
-            <a:endParaRPr lang="en-US"/>
-          </a:p>
-        </p:txBody>
-      </p:sp>
-      <p:sp>
-        <p:nvSpPr>
-          <p:cNvPr id="9" name="Text 7"/>
-          <p:cNvSpPr/>
-          <p:nvPr/>
-        </p:nvSpPr>
-        <p:spPr>
-          <a:xfrm>
-            <a:off x="719176" y="2286000"/>
-            <a:ext cx="1371600" cy="457200"/>
-          </a:xfrm>
-          <a:prstGeom prst="rect">
-            <a:avLst/>
-          </a:prstGeom>
-          <a:noFill/>
-          <a:ln/>
-        </p:spPr>
-        <p:txBody>
-          <a:bodyPr wrap="square" lIns="0" tIns="0" rIns="0" bIns="0" rtlCol="0" anchor="ctr"/>
-          <a:lstStyle/>
-          <a:p>
-            <a:pPr marL="0" indent="0">
-              <a:buNone/>
-            </a:pPr>
-            <a:r>
-              <a:rPr lang="en-US" sz="2200" b="1" dirty="0">
-                <a:solidFill>
-                  <a:srgbClr val="14B8A6"/>
-                </a:solidFill>
-                <a:latin typeface="Georgia" pitchFamily="34" charset="0"/>
-                <a:ea typeface="Georgia" pitchFamily="34" charset="-122"/>
-                <a:cs typeface="Georgia" pitchFamily="34" charset="-120"/>
-              </a:rPr>
-              <a:t>01</a:t>
-            </a:r>
-            <a:endParaRPr lang="en-US" sz="2200" dirty="0"/>
-          </a:p>
-        </p:txBody>
-      </p:sp>
-      <p:sp>
-        <p:nvSpPr>
-          <p:cNvPr id="10" name="Text 8"/>
-          <p:cNvSpPr/>
-          <p:nvPr/>
-        </p:nvSpPr>
-        <p:spPr>
-          <a:xfrm>
-            <a:off x="719176" y="2697480"/>
-            <a:ext cx="3108960" cy="365760"/>
-          </a:xfrm>
-          <a:prstGeom prst="rect">
-            <a:avLst/>
-          </a:prstGeom>
-          <a:noFill/>
-          <a:ln/>
-        </p:spPr>
-        <p:txBody>
-          <a:bodyPr wrap="square" lIns="0" tIns="0" rIns="0" bIns="0" rtlCol="0" anchor="ctr"/>
-          <a:lstStyle/>
-          <a:p>
-            <a:pPr marL="0" indent="0">
-              <a:buNone/>
-            </a:pPr>
-            <a:r>
-              <a:rPr lang="en-US" sz="1300" b="1" dirty="0">
-                <a:solidFill>
-                  <a:srgbClr val="0F172A"/>
-                </a:solidFill>
-                <a:latin typeface="Calibri" pitchFamily="34" charset="0"/>
-                <a:ea typeface="Calibri" pitchFamily="34" charset="-122"/>
-                <a:cs typeface="Calibri" pitchFamily="34" charset="-120"/>
-              </a:rPr>
-              <a:t>Sitemap-first discovery</a:t>
-            </a:r>
-            <a:endParaRPr lang="en-US" sz="1300" dirty="0"/>
-          </a:p>
-        </p:txBody>
-      </p:sp>
-      <p:sp>
-        <p:nvSpPr>
-          <p:cNvPr id="11" name="Text 9"/>
-          <p:cNvSpPr/>
-          <p:nvPr/>
-        </p:nvSpPr>
-        <p:spPr>
-          <a:xfrm>
-            <a:off x="719176" y="3063240"/>
-            <a:ext cx="3108960" cy="777240"/>
-          </a:xfrm>
-          <a:prstGeom prst="rect">
-            <a:avLst/>
-          </a:prstGeom>
-          <a:noFill/>
-          <a:ln/>
-        </p:spPr>
-        <p:txBody>
-          <a:bodyPr wrap="square" lIns="0" tIns="0" rIns="0" bIns="0" rtlCol="0" anchor="ctr"/>
-          <a:lstStyle/>
-          <a:p>
-            <a:pPr marL="0" indent="0">
-              <a:buNone/>
-            </a:pPr>
-            <a:r>
-              <a:rPr lang="en-US" sz="1050" dirty="0">
-                <a:solidFill>
-                  <a:srgbClr val="1E293B"/>
-                </a:solidFill>
-                <a:latin typeface="Calibri" pitchFamily="34" charset="0"/>
-                <a:ea typeface="Calibri" pitchFamily="34" charset="-122"/>
-                <a:cs typeface="Calibri" pitchFamily="34" charset="-120"/>
-              </a:rPr>
-              <a:t>Skip link-graph crawling entirely. Sitemaps already enumerate canonical URLs the site wants indexed — no DOM parsing needed.</a:t>
-            </a:r>
-            <a:endParaRPr lang="en-US" sz="1050" dirty="0"/>
-          </a:p>
-        </p:txBody>
-      </p:sp>
-      <p:sp>
-        <p:nvSpPr>
-          <p:cNvPr id="12" name="Shape 10"/>
-          <p:cNvSpPr/>
-          <p:nvPr/>
-        </p:nvSpPr>
-        <p:spPr>
-          <a:xfrm>
-            <a:off x="4267048" y="2103120"/>
-            <a:ext cx="3657600" cy="1828800"/>
-          </a:xfrm>
-          <a:prstGeom prst="rect">
-            <a:avLst/>
-          </a:prstGeom>
-          <a:solidFill>
-            <a:srgbClr val="FFFFFF"/>
-          </a:solidFill>
-          <a:ln w="12700">
-            <a:solidFill>
-              <a:srgbClr val="E2E8F0"/>
-            </a:solidFill>
-            <a:prstDash val="solid"/>
-          </a:ln>
-          <a:effectLst>
-            <a:outerShdw blurRad="101600" dist="25400" dir="5400000" algn="bl" rotWithShape="0">
-              <a:srgbClr val="0F172A">
-                <a:alpha val="8000"/>
-              </a:srgbClr>
-            </a:outerShdw>
-          </a:effectLst>
-        </p:spPr>
-        <p:txBody>
-          <a:bodyPr/>
-          <a:lstStyle/>
-          <a:p>
-            <a:endParaRPr lang="en-US"/>
-          </a:p>
-        </p:txBody>
-      </p:sp>
-      <p:sp>
-        <p:nvSpPr>
-          <p:cNvPr id="13" name="Text 11"/>
-          <p:cNvSpPr/>
-          <p:nvPr/>
-        </p:nvSpPr>
-        <p:spPr>
-          <a:xfrm>
-            <a:off x="4541368" y="2286000"/>
-            <a:ext cx="1371600" cy="457200"/>
-          </a:xfrm>
-          <a:prstGeom prst="rect">
-            <a:avLst/>
-          </a:prstGeom>
-          <a:noFill/>
-          <a:ln/>
-        </p:spPr>
-        <p:txBody>
-          <a:bodyPr wrap="square" lIns="0" tIns="0" rIns="0" bIns="0" rtlCol="0" anchor="ctr"/>
-          <a:lstStyle/>
-          <a:p>
-            <a:pPr marL="0" indent="0">
-              <a:buNone/>
-            </a:pPr>
-            <a:r>
-              <a:rPr lang="en-US" sz="2200" b="1" dirty="0">
-                <a:solidFill>
-                  <a:srgbClr val="14B8A6"/>
-                </a:solidFill>
-                <a:latin typeface="Georgia" pitchFamily="34" charset="0"/>
-                <a:ea typeface="Georgia" pitchFamily="34" charset="-122"/>
-                <a:cs typeface="Georgia" pitchFamily="34" charset="-120"/>
-              </a:rPr>
-              <a:t>02</a:t>
-            </a:r>
-            <a:endParaRPr lang="en-US" sz="2200" dirty="0"/>
-          </a:p>
-        </p:txBody>
-      </p:sp>
-      <p:sp>
-        <p:nvSpPr>
-          <p:cNvPr id="14" name="Text 12"/>
-          <p:cNvSpPr/>
-          <p:nvPr/>
-        </p:nvSpPr>
-        <p:spPr>
-          <a:xfrm>
-            <a:off x="4541368" y="2697480"/>
-            <a:ext cx="3108960" cy="365760"/>
-          </a:xfrm>
-          <a:prstGeom prst="rect">
-            <a:avLst/>
-          </a:prstGeom>
-          <a:noFill/>
-          <a:ln/>
-        </p:spPr>
-        <p:txBody>
-          <a:bodyPr wrap="square" lIns="0" tIns="0" rIns="0" bIns="0" rtlCol="0" anchor="ctr"/>
-          <a:lstStyle/>
-          <a:p>
-            <a:pPr marL="0" indent="0">
-              <a:buNone/>
-            </a:pPr>
-            <a:r>
-              <a:rPr lang="en-US" sz="1300" b="1" dirty="0">
-                <a:solidFill>
-                  <a:srgbClr val="0F172A"/>
-                </a:solidFill>
-                <a:latin typeface="Calibri" pitchFamily="34" charset="0"/>
-                <a:ea typeface="Calibri" pitchFamily="34" charset="-122"/>
-                <a:cs typeface="Calibri" pitchFamily="34" charset="-120"/>
-              </a:rPr>
-              <a:t>Topic filtering at sitemap level</a:t>
-            </a:r>
-            <a:endParaRPr lang="en-US" sz="1300" dirty="0"/>
-          </a:p>
-        </p:txBody>
-      </p:sp>
-      <p:sp>
-        <p:nvSpPr>
-          <p:cNvPr id="15" name="Text 13"/>
-          <p:cNvSpPr/>
-          <p:nvPr/>
-        </p:nvSpPr>
-        <p:spPr>
-          <a:xfrm>
-            <a:off x="4541368" y="3063240"/>
-            <a:ext cx="3108960" cy="777240"/>
-          </a:xfrm>
-          <a:prstGeom prst="rect">
-            <a:avLst/>
-          </a:prstGeom>
-          <a:noFill/>
-          <a:ln/>
-        </p:spPr>
-        <p:txBody>
-          <a:bodyPr wrap="square" lIns="0" tIns="0" rIns="0" bIns="0" rtlCol="0" anchor="ctr"/>
-          <a:lstStyle/>
-          <a:p>
-            <a:pPr marL="0" indent="0">
-              <a:buNone/>
-            </a:pPr>
-            <a:r>
-              <a:rPr lang="en-US" sz="1050" dirty="0">
-                <a:solidFill>
-                  <a:srgbClr val="1E293B"/>
-                </a:solidFill>
-                <a:latin typeface="Calibri" pitchFamily="34" charset="0"/>
-                <a:ea typeface="Calibri" pitchFamily="34" charset="-122"/>
-                <a:cs typeface="Calibri" pitchFamily="34" charset="-120"/>
-              </a:rPr>
-              <a:t>Regex against raw sitemap XML before fetching any HTML. One sitemap rejects thousands of irrelevant URLs in a single check.</a:t>
-            </a:r>
-            <a:endParaRPr lang="en-US" sz="1050" dirty="0"/>
-          </a:p>
-        </p:txBody>
-      </p:sp>
-      <p:sp>
-        <p:nvSpPr>
-          <p:cNvPr id="16" name="Shape 14"/>
-          <p:cNvSpPr/>
-          <p:nvPr/>
-        </p:nvSpPr>
-        <p:spPr>
-          <a:xfrm>
-            <a:off x="8089240" y="2103120"/>
-            <a:ext cx="3657600" cy="1828800"/>
-          </a:xfrm>
-          <a:prstGeom prst="rect">
-            <a:avLst/>
-          </a:prstGeom>
-          <a:solidFill>
-            <a:srgbClr val="FFFFFF"/>
-          </a:solidFill>
-          <a:ln w="12700">
-            <a:solidFill>
-              <a:srgbClr val="E2E8F0"/>
-            </a:solidFill>
-            <a:prstDash val="solid"/>
-          </a:ln>
-          <a:effectLst>
-            <a:outerShdw blurRad="101600" dist="25400" dir="5400000" algn="bl" rotWithShape="0">
-              <a:srgbClr val="0F172A">
-                <a:alpha val="8000"/>
-              </a:srgbClr>
-            </a:outerShdw>
-          </a:effectLst>
-        </p:spPr>
-        <p:txBody>
-          <a:bodyPr/>
-          <a:lstStyle/>
-          <a:p>
-            <a:endParaRPr lang="en-US"/>
-          </a:p>
-        </p:txBody>
-      </p:sp>
-      <p:sp>
-        <p:nvSpPr>
-          <p:cNvPr id="17" name="Text 15"/>
-          <p:cNvSpPr/>
-          <p:nvPr/>
-        </p:nvSpPr>
-        <p:spPr>
-          <a:xfrm>
-            <a:off x="8363560" y="2286000"/>
-            <a:ext cx="1371600" cy="457200"/>
-          </a:xfrm>
-          <a:prstGeom prst="rect">
-            <a:avLst/>
-          </a:prstGeom>
-          <a:noFill/>
-          <a:ln/>
-        </p:spPr>
-        <p:txBody>
-          <a:bodyPr wrap="square" lIns="0" tIns="0" rIns="0" bIns="0" rtlCol="0" anchor="ctr"/>
-          <a:lstStyle/>
-          <a:p>
-            <a:pPr marL="0" indent="0">
-              <a:buNone/>
-            </a:pPr>
-            <a:r>
-              <a:rPr lang="en-US" sz="2200" b="1" dirty="0">
-                <a:solidFill>
-                  <a:srgbClr val="14B8A6"/>
-                </a:solidFill>
-                <a:latin typeface="Georgia" pitchFamily="34" charset="0"/>
-                <a:ea typeface="Georgia" pitchFamily="34" charset="-122"/>
-                <a:cs typeface="Georgia" pitchFamily="34" charset="-120"/>
-              </a:rPr>
-              <a:t>03</a:t>
-            </a:r>
-            <a:endParaRPr lang="en-US" sz="2200" dirty="0"/>
-          </a:p>
-        </p:txBody>
-      </p:sp>
-      <p:sp>
-        <p:nvSpPr>
-          <p:cNvPr id="18" name="Text 16"/>
-          <p:cNvSpPr/>
-          <p:nvPr/>
-        </p:nvSpPr>
-        <p:spPr>
-          <a:xfrm>
-            <a:off x="8363560" y="2697480"/>
-            <a:ext cx="3108960" cy="365760"/>
-          </a:xfrm>
-          <a:prstGeom prst="rect">
-            <a:avLst/>
-          </a:prstGeom>
-          <a:noFill/>
-          <a:ln/>
-        </p:spPr>
-        <p:txBody>
-          <a:bodyPr wrap="square" lIns="0" tIns="0" rIns="0" bIns="0" rtlCol="0" anchor="ctr"/>
-          <a:lstStyle/>
-          <a:p>
-            <a:pPr marL="0" indent="0">
-              <a:buNone/>
-            </a:pPr>
-            <a:r>
-              <a:rPr lang="en-US" sz="1300" b="1" dirty="0">
-                <a:solidFill>
-                  <a:srgbClr val="0F172A"/>
-                </a:solidFill>
-                <a:latin typeface="Calibri" pitchFamily="34" charset="0"/>
-                <a:ea typeface="Calibri" pitchFamily="34" charset="-122"/>
-                <a:cs typeface="Calibri" pitchFamily="34" charset="-120"/>
-              </a:rPr>
-              <a:t>Word-boundary regex matching</a:t>
-            </a:r>
-            <a:endParaRPr lang="en-US" sz="1300" dirty="0"/>
-          </a:p>
-        </p:txBody>
-      </p:sp>
-      <p:sp>
-        <p:nvSpPr>
-          <p:cNvPr id="19" name="Text 17"/>
-          <p:cNvSpPr/>
-          <p:nvPr/>
-        </p:nvSpPr>
-        <p:spPr>
-          <a:xfrm>
-            <a:off x="8363560" y="3063240"/>
-            <a:ext cx="3108960" cy="777240"/>
-          </a:xfrm>
-          <a:prstGeom prst="rect">
-            <a:avLst/>
-          </a:prstGeom>
-          <a:noFill/>
-          <a:ln/>
-        </p:spPr>
-        <p:txBody>
-          <a:bodyPr wrap="square" lIns="0" tIns="0" rIns="0" bIns="0" rtlCol="0" anchor="ctr"/>
-          <a:lstStyle/>
-          <a:p>
-            <a:pPr marL="0" indent="0">
-              <a:buNone/>
-            </a:pPr>
-            <a:r>
-              <a:rPr lang="en-US" sz="1050" dirty="0">
-                <a:solidFill>
-                  <a:srgbClr val="1E293B"/>
-                </a:solidFill>
-                <a:latin typeface="Calibri" pitchFamily="34" charset="0"/>
-                <a:ea typeface="Calibri" pitchFamily="34" charset="-122"/>
-                <a:cs typeface="Calibri" pitchFamily="34" charset="-120"/>
-              </a:rPr>
-              <a:t>\bukraine\b avoids false positives like "ukrainian" or partial substring noise — fewer wasted page downloads.</a:t>
-            </a:r>
-            <a:endParaRPr lang="en-US" sz="1050" dirty="0"/>
-          </a:p>
-        </p:txBody>
-      </p:sp>
-      <p:sp>
-        <p:nvSpPr>
-          <p:cNvPr id="20" name="Shape 18"/>
-          <p:cNvSpPr/>
-          <p:nvPr/>
-        </p:nvSpPr>
-        <p:spPr>
-          <a:xfrm>
-            <a:off x="444856" y="4096512"/>
-            <a:ext cx="3657600" cy="1828800"/>
-          </a:xfrm>
-          <a:prstGeom prst="rect">
-            <a:avLst/>
-          </a:prstGeom>
-          <a:solidFill>
-            <a:srgbClr val="FFFFFF"/>
-          </a:solidFill>
-          <a:ln w="12700">
-            <a:solidFill>
-              <a:srgbClr val="E2E8F0"/>
-            </a:solidFill>
-            <a:prstDash val="solid"/>
-          </a:ln>
-          <a:effectLst>
-            <a:outerShdw blurRad="101600" dist="25400" dir="5400000" algn="bl" rotWithShape="0">
-              <a:srgbClr val="0F172A">
-                <a:alpha val="8000"/>
-              </a:srgbClr>
-            </a:outerShdw>
-          </a:effectLst>
-        </p:spPr>
-        <p:txBody>
-          <a:bodyPr/>
-          <a:lstStyle/>
-          <a:p>
-            <a:endParaRPr lang="en-US"/>
-          </a:p>
-        </p:txBody>
-      </p:sp>
-      <p:sp>
-        <p:nvSpPr>
-          <p:cNvPr id="21" name="Text 19"/>
-          <p:cNvSpPr/>
-          <p:nvPr/>
-        </p:nvSpPr>
-        <p:spPr>
-          <a:xfrm>
-            <a:off x="719176" y="4279392"/>
-            <a:ext cx="1371600" cy="457200"/>
-          </a:xfrm>
-          <a:prstGeom prst="rect">
-            <a:avLst/>
-          </a:prstGeom>
-          <a:noFill/>
-          <a:ln/>
-        </p:spPr>
-        <p:txBody>
-          <a:bodyPr wrap="square" lIns="0" tIns="0" rIns="0" bIns="0" rtlCol="0" anchor="ctr"/>
-          <a:lstStyle/>
-          <a:p>
-            <a:pPr marL="0" indent="0">
-              <a:buNone/>
-            </a:pPr>
-            <a:r>
-              <a:rPr lang="en-US" sz="2200" b="1" dirty="0">
-                <a:solidFill>
-                  <a:srgbClr val="14B8A6"/>
-                </a:solidFill>
-                <a:latin typeface="Georgia"/>
-              </a:rPr>
-              <a:t>04</a:t>
-            </a:r>
-            <a:endParaRPr lang="en-US" sz="2200">
-              <a:solidFill>
-                <a:srgbClr val="000000"/>
-              </a:solidFill>
-              <a:latin typeface="Calibri"/>
-              <a:ea typeface="Calibri"/>
-              <a:cs typeface="Calibri"/>
-            </a:endParaRPr>
-          </a:p>
-        </p:txBody>
-      </p:sp>
-      <p:sp>
-        <p:nvSpPr>
-          <p:cNvPr id="22" name="Text 20"/>
-          <p:cNvSpPr/>
-          <p:nvPr/>
-        </p:nvSpPr>
-        <p:spPr>
-          <a:xfrm>
-            <a:off x="719176" y="4690872"/>
-            <a:ext cx="3108960" cy="365760"/>
-          </a:xfrm>
-          <a:prstGeom prst="rect">
-            <a:avLst/>
-          </a:prstGeom>
-          <a:noFill/>
-          <a:ln/>
-        </p:spPr>
-        <p:txBody>
-          <a:bodyPr wrap="square" lIns="0" tIns="0" rIns="0" bIns="0" rtlCol="0" anchor="ctr"/>
-          <a:lstStyle/>
-          <a:p>
-            <a:pPr marL="0" indent="0">
-              <a:buNone/>
-            </a:pPr>
-            <a:r>
-              <a:rPr lang="en-US" sz="1300" b="1" dirty="0">
-                <a:solidFill>
-                  <a:srgbClr val="0F172A"/>
-                </a:solidFill>
-                <a:latin typeface="Calibri" pitchFamily="34" charset="0"/>
-                <a:ea typeface="Calibri" pitchFamily="34" charset="-122"/>
-                <a:cs typeface="Calibri" pitchFamily="34" charset="-120"/>
-              </a:rPr>
-              <a:t>Persisted XML cache</a:t>
-            </a:r>
-            <a:endParaRPr lang="en-US" sz="1300" dirty="0"/>
-          </a:p>
-        </p:txBody>
-      </p:sp>
-      <p:sp>
-        <p:nvSpPr>
-          <p:cNvPr id="23" name="Text 21"/>
-          <p:cNvSpPr/>
-          <p:nvPr/>
-        </p:nvSpPr>
-        <p:spPr>
-          <a:xfrm>
-            <a:off x="719176" y="5056632"/>
-            <a:ext cx="3108960" cy="777240"/>
-          </a:xfrm>
-          <a:prstGeom prst="rect">
-            <a:avLst/>
-          </a:prstGeom>
-          <a:noFill/>
-          <a:ln/>
-        </p:spPr>
-        <p:txBody>
-          <a:bodyPr wrap="square" lIns="0" tIns="0" rIns="0" bIns="0" rtlCol="0" anchor="ctr"/>
-          <a:lstStyle/>
-          <a:p>
-            <a:pPr marL="0" indent="0">
-              <a:buNone/>
-            </a:pPr>
-            <a:r>
-              <a:rPr lang="en-US" sz="1050">
-                <a:solidFill>
-                  <a:srgbClr val="1E293B"/>
-                </a:solidFill>
-                <a:latin typeface="Calibri"/>
-                <a:ea typeface="Calibri"/>
-                <a:cs typeface="Calibri"/>
-              </a:rPr>
-              <a:t>Sitemaps are written to /_pages/&lt;topic&gt;/. </a:t>
-            </a:r>
-          </a:p>
-        </p:txBody>
-      </p:sp>
-      <p:sp>
-        <p:nvSpPr>
-          <p:cNvPr id="24" name="Shape 22"/>
-          <p:cNvSpPr/>
-          <p:nvPr/>
-        </p:nvSpPr>
-        <p:spPr>
-          <a:xfrm>
-            <a:off x="4267048" y="4096512"/>
-            <a:ext cx="3657600" cy="1828800"/>
-          </a:xfrm>
-          <a:prstGeom prst="rect">
-            <a:avLst/>
-          </a:prstGeom>
-          <a:solidFill>
-            <a:srgbClr val="FFFFFF"/>
-          </a:solidFill>
-          <a:ln w="12700">
-            <a:solidFill>
-              <a:srgbClr val="E2E8F0"/>
-            </a:solidFill>
-            <a:prstDash val="solid"/>
-          </a:ln>
-          <a:effectLst>
-            <a:outerShdw blurRad="101600" dist="25400" dir="5400000" algn="bl" rotWithShape="0">
-              <a:srgbClr val="0F172A">
-                <a:alpha val="8000"/>
-              </a:srgbClr>
-            </a:outerShdw>
-          </a:effectLst>
-        </p:spPr>
-        <p:txBody>
-          <a:bodyPr/>
-          <a:lstStyle/>
-          <a:p>
-            <a:endParaRPr lang="en-US"/>
-          </a:p>
-        </p:txBody>
-      </p:sp>
-      <p:sp>
-        <p:nvSpPr>
-          <p:cNvPr id="25" name="Text 23"/>
-          <p:cNvSpPr/>
-          <p:nvPr/>
-        </p:nvSpPr>
-        <p:spPr>
-          <a:xfrm>
-            <a:off x="4541368" y="4279392"/>
-            <a:ext cx="1371600" cy="457200"/>
-          </a:xfrm>
-          <a:prstGeom prst="rect">
-            <a:avLst/>
-          </a:prstGeom>
-          <a:noFill/>
-          <a:ln/>
-        </p:spPr>
-        <p:txBody>
-          <a:bodyPr wrap="square" lIns="0" tIns="0" rIns="0" bIns="0" rtlCol="0" anchor="ctr"/>
-          <a:lstStyle/>
-          <a:p>
-            <a:pPr marL="0" indent="0">
-              <a:buNone/>
-            </a:pPr>
-            <a:r>
-              <a:rPr lang="en-US" sz="2200" b="1" dirty="0">
-                <a:solidFill>
-                  <a:srgbClr val="14B8A6"/>
-                </a:solidFill>
-                <a:latin typeface="Georgia" pitchFamily="34" charset="0"/>
-                <a:ea typeface="Georgia" pitchFamily="34" charset="-122"/>
-                <a:cs typeface="Georgia" pitchFamily="34" charset="-120"/>
-              </a:rPr>
-              <a:t>05</a:t>
-            </a:r>
-            <a:endParaRPr lang="en-US" sz="2200" dirty="0"/>
-          </a:p>
-        </p:txBody>
-      </p:sp>
-      <p:sp>
-        <p:nvSpPr>
-          <p:cNvPr id="26" name="Text 24"/>
-          <p:cNvSpPr/>
-          <p:nvPr/>
-        </p:nvSpPr>
-        <p:spPr>
-          <a:xfrm>
-            <a:off x="4541368" y="4690872"/>
-            <a:ext cx="3108960" cy="365760"/>
-          </a:xfrm>
-          <a:prstGeom prst="rect">
-            <a:avLst/>
-          </a:prstGeom>
-          <a:noFill/>
-          <a:ln/>
-        </p:spPr>
-        <p:txBody>
-          <a:bodyPr wrap="square" lIns="0" tIns="0" rIns="0" bIns="0" rtlCol="0" anchor="ctr"/>
-          <a:lstStyle/>
-          <a:p>
-            <a:pPr marL="0" indent="0">
-              <a:buNone/>
-            </a:pPr>
-            <a:r>
-              <a:rPr lang="en-US" sz="1300" b="1" dirty="0">
-                <a:solidFill>
-                  <a:srgbClr val="0F172A"/>
-                </a:solidFill>
-                <a:latin typeface="Calibri" pitchFamily="34" charset="0"/>
-                <a:ea typeface="Calibri" pitchFamily="34" charset="-122"/>
-                <a:cs typeface="Calibri" pitchFamily="34" charset="-120"/>
-              </a:rPr>
-              <a:t>Streamed file writes</a:t>
-            </a:r>
-            <a:endParaRPr lang="en-US" sz="1300" dirty="0"/>
-          </a:p>
-        </p:txBody>
-      </p:sp>
-      <p:sp>
-        <p:nvSpPr>
-          <p:cNvPr id="27" name="Text 25"/>
-          <p:cNvSpPr/>
-          <p:nvPr/>
-        </p:nvSpPr>
-        <p:spPr>
-          <a:xfrm>
-            <a:off x="4541368" y="5056632"/>
-            <a:ext cx="3108960" cy="777240"/>
-          </a:xfrm>
-          <a:prstGeom prst="rect">
-            <a:avLst/>
-          </a:prstGeom>
-          <a:noFill/>
-          <a:ln/>
-        </p:spPr>
-        <p:txBody>
-          <a:bodyPr wrap="square" lIns="0" tIns="0" rIns="0" bIns="0" rtlCol="0" anchor="ctr"/>
-          <a:lstStyle/>
-          <a:p>
-            <a:pPr marL="0" indent="0">
-              <a:buNone/>
-            </a:pPr>
-            <a:r>
-              <a:rPr lang="en-US" sz="1050" dirty="0">
-                <a:solidFill>
-                  <a:srgbClr val="1E293B"/>
-                </a:solidFill>
-                <a:latin typeface="Calibri" pitchFamily="34" charset="0"/>
-                <a:ea typeface="Calibri" pitchFamily="34" charset="-122"/>
-                <a:cs typeface="Calibri" pitchFamily="34" charset="-120"/>
-              </a:rPr>
-              <a:t>Open / write / close per file; HTML never accumulates in memory across the run.</a:t>
-            </a:r>
-            <a:endParaRPr lang="en-US" sz="1050" dirty="0"/>
-          </a:p>
-        </p:txBody>
-      </p:sp>
-      <p:sp>
-        <p:nvSpPr>
-          <p:cNvPr id="28" name="Shape 26"/>
-          <p:cNvSpPr/>
-          <p:nvPr/>
-        </p:nvSpPr>
-        <p:spPr>
-          <a:xfrm>
-            <a:off x="8089240" y="4096512"/>
-            <a:ext cx="3657600" cy="1828800"/>
-          </a:xfrm>
-          <a:prstGeom prst="rect">
-            <a:avLst/>
-          </a:prstGeom>
-          <a:solidFill>
-            <a:srgbClr val="FFFFFF"/>
-          </a:solidFill>
-          <a:ln w="12700">
-            <a:solidFill>
-              <a:srgbClr val="E2E8F0"/>
-            </a:solidFill>
-            <a:prstDash val="solid"/>
-          </a:ln>
-          <a:effectLst>
-            <a:outerShdw blurRad="101600" dist="25400" dir="5400000" algn="bl" rotWithShape="0">
-              <a:srgbClr val="0F172A">
-                <a:alpha val="8000"/>
-              </a:srgbClr>
-            </a:outerShdw>
-          </a:effectLst>
-        </p:spPr>
-        <p:txBody>
-          <a:bodyPr/>
-          <a:lstStyle/>
-          <a:p>
-            <a:endParaRPr lang="en-US"/>
-          </a:p>
-        </p:txBody>
-      </p:sp>
-      <p:sp>
-        <p:nvSpPr>
-          <p:cNvPr id="29" name="Text 27"/>
-          <p:cNvSpPr/>
-          <p:nvPr/>
-        </p:nvSpPr>
-        <p:spPr>
-          <a:xfrm>
-            <a:off x="8363560" y="4279392"/>
-            <a:ext cx="1371600" cy="457200"/>
-          </a:xfrm>
-          <a:prstGeom prst="rect">
-            <a:avLst/>
-          </a:prstGeom>
-          <a:noFill/>
-          <a:ln/>
-        </p:spPr>
-        <p:txBody>
-          <a:bodyPr wrap="square" lIns="0" tIns="0" rIns="0" bIns="0" rtlCol="0" anchor="ctr"/>
-          <a:lstStyle/>
-          <a:p>
-            <a:pPr marL="0" indent="0">
-              <a:buNone/>
-            </a:pPr>
-            <a:r>
-              <a:rPr lang="en-US" sz="2200" b="1" dirty="0">
-                <a:solidFill>
-                  <a:srgbClr val="14B8A6"/>
-                </a:solidFill>
-                <a:latin typeface="Georgia" pitchFamily="34" charset="0"/>
-                <a:ea typeface="Georgia" pitchFamily="34" charset="-122"/>
-                <a:cs typeface="Georgia" pitchFamily="34" charset="-120"/>
-              </a:rPr>
-              <a:t>06</a:t>
-            </a:r>
-            <a:endParaRPr lang="en-US" sz="2200" dirty="0"/>
-          </a:p>
-        </p:txBody>
-      </p:sp>
-      <p:sp>
-        <p:nvSpPr>
-          <p:cNvPr id="30" name="Text 28"/>
-          <p:cNvSpPr/>
-          <p:nvPr/>
-        </p:nvSpPr>
-        <p:spPr>
-          <a:xfrm>
-            <a:off x="8363560" y="4690872"/>
-            <a:ext cx="3108960" cy="365760"/>
-          </a:xfrm>
-          <a:prstGeom prst="rect">
-            <a:avLst/>
-          </a:prstGeom>
-          <a:noFill/>
-          <a:ln/>
-        </p:spPr>
-        <p:txBody>
-          <a:bodyPr wrap="square" lIns="0" tIns="0" rIns="0" bIns="0" rtlCol="0" anchor="ctr"/>
-          <a:lstStyle/>
-          <a:p>
-            <a:pPr marL="0" indent="0">
-              <a:buNone/>
-            </a:pPr>
-            <a:r>
-              <a:rPr lang="en-US" sz="1300" b="1" dirty="0">
-                <a:solidFill>
-                  <a:srgbClr val="0F172A"/>
-                </a:solidFill>
-                <a:latin typeface="Calibri" pitchFamily="34" charset="0"/>
-                <a:ea typeface="Calibri" pitchFamily="34" charset="-122"/>
-                <a:cs typeface="Calibri" pitchFamily="34" charset="-120"/>
-              </a:rPr>
-              <a:t>Single-purpose pipeline</a:t>
-            </a:r>
-            <a:endParaRPr lang="en-US" sz="1300" dirty="0"/>
-          </a:p>
-        </p:txBody>
-      </p:sp>
-      <p:sp>
-        <p:nvSpPr>
-          <p:cNvPr id="31" name="Text 29"/>
-          <p:cNvSpPr/>
-          <p:nvPr/>
-        </p:nvSpPr>
-        <p:spPr>
-          <a:xfrm>
-            <a:off x="8363560" y="5056632"/>
-            <a:ext cx="3108960" cy="777240"/>
-          </a:xfrm>
-          <a:prstGeom prst="rect">
-            <a:avLst/>
-          </a:prstGeom>
-          <a:noFill/>
-          <a:ln/>
-        </p:spPr>
-        <p:txBody>
-          <a:bodyPr wrap="square" lIns="0" tIns="0" rIns="0" bIns="0" rtlCol="0" anchor="ctr"/>
-          <a:lstStyle/>
-          <a:p>
-            <a:pPr marL="0" indent="0">
-              <a:buNone/>
-            </a:pPr>
-            <a:r>
-              <a:rPr lang="en-US" sz="1050" dirty="0">
-                <a:solidFill>
-                  <a:srgbClr val="1E293B"/>
-                </a:solidFill>
-                <a:latin typeface="Calibri" pitchFamily="34" charset="0"/>
-                <a:ea typeface="Calibri" pitchFamily="34" charset="-122"/>
-                <a:cs typeface="Calibri" pitchFamily="34" charset="-120"/>
-              </a:rPr>
-              <a:t>parse → store → download. Each stage is independent and re-runnable on its own outputs.</a:t>
-            </a:r>
-            <a:endParaRPr lang="en-US" sz="1050" dirty="0"/>
-          </a:p>
-        </p:txBody>
-      </p:sp>
-    </p:spTree>
-  </p:cSld>
-  <p:clrMapOvr>
-    <a:masterClrMapping/>
-  </p:clrMapOvr>
-</p:sld>
-</file>
-
-<file path=ppt/slides/slide11.xml><?xml version="1.0" encoding="utf-8"?>
-<p:sld xmlns:a="http://schemas.openxmlformats.org/drawingml/2006/main" xmlns:r="http://schemas.openxmlformats.org/officeDocument/2006/relationships" xmlns:p="http://schemas.openxmlformats.org/presentationml/2006/main">
   <p:cSld name="Slide 11">
     <p:bg>
       <p:bgPr>
@@ -5159,7 +3879,7 @@
 </p:sld>
 </file>
 
-<file path=ppt/slides/slide12.xml><?xml version="1.0" encoding="utf-8"?>
+<file path=ppt/slides/slide11.xml><?xml version="1.0" encoding="utf-8"?>
 <p:sld xmlns:a="http://schemas.openxmlformats.org/drawingml/2006/main" xmlns:r="http://schemas.openxmlformats.org/officeDocument/2006/relationships" xmlns:p="http://schemas.openxmlformats.org/presentationml/2006/main">
   <p:cSld name="Slide 12">
     <p:bg>
@@ -5493,7 +4213,7 @@
                 <a:ea typeface="Calibri" pitchFamily="34" charset="-122"/>
                 <a:cs typeface="Calibri" pitchFamily="34" charset="-120"/>
               </a:rPr>
-              <a:t>Two-class object-oriented design with a procedural script driver — Crawler does the work, Logger records it. No persistent state between runs except log.txt and downloaded artifacts on disk.</a:t>
+              <a:t>Two classes. Procedural approach — Crawler does the work, Logger records it. No persistent state between runs except log.txt and downloaded artifacts on disk.</a:t>
             </a:r>
             <a:endParaRPr lang="en-US" sz="1150" dirty="0"/>
           </a:p>
@@ -6982,7 +5702,7 @@
 </p:sld>
 </file>
 
-<file path=ppt/slides/slide13.xml><?xml version="1.0" encoding="utf-8"?>
+<file path=ppt/slides/slide12.xml><?xml version="1.0" encoding="utf-8"?>
 <p:sld xmlns:a="http://schemas.openxmlformats.org/drawingml/2006/main" xmlns:r="http://schemas.openxmlformats.org/officeDocument/2006/relationships" xmlns:p="http://schemas.openxmlformats.org/presentationml/2006/main">
   <p:cSld name="Slide 13">
     <p:bg>
@@ -7957,7 +6677,7 @@
 </p:sld>
 </file>
 
-<file path=ppt/slides/slide14.xml><?xml version="1.0" encoding="utf-8"?>
+<file path=ppt/slides/slide13.xml><?xml version="1.0" encoding="utf-8"?>
 <p:sld xmlns:a="http://schemas.openxmlformats.org/drawingml/2006/main" xmlns:r="http://schemas.openxmlformats.org/officeDocument/2006/relationships" xmlns:p="http://schemas.openxmlformats.org/presentationml/2006/main">
   <p:cSld name="Slide 14">
     <p:bg>
@@ -10298,7 +9018,7 @@
                 <a:ea typeface="Calibri" pitchFamily="34" charset="-122"/>
                 <a:cs typeface="Calibri" pitchFamily="34" charset="-120"/>
               </a:rPr>
-              <a:t>Roles distributed across crawler design, security analysis, and documentation. Names to be filled by the team.</a:t>
+              <a:t>Roles distributed across crawler design, security analysis, and documentation.</a:t>
             </a:r>
             <a:endParaRPr lang="en-US" sz="1300" dirty="0"/>
           </a:p>
@@ -10313,7 +9033,7 @@
           <p:nvPr>
             <p:extLst>
               <p:ext uri="{D42A27DB-BD31-4B8C-83A1-F6EECF244321}">
-                <p14:modId xmlns:p14="http://schemas.microsoft.com/office/powerpoint/2010/main" val="2399054450"/>
+                <p14:modId xmlns:p14="http://schemas.microsoft.com/office/powerpoint/2010/main" val="2386619345"/>
               </p:ext>
             </p:extLst>
           </p:nvPr>
@@ -11249,7 +9969,7 @@
                           <a:ea typeface="Calibri" pitchFamily="34" charset="-122"/>
                           <a:cs typeface="Calibri" pitchFamily="34" charset="-120"/>
                         </a:rPr>
-                        <a:t>Testing, demo target selection, presentation slides, README</a:t>
+                        <a:t>Testing, demo target selection, presentation slides</a:t>
                       </a:r>
                       <a:endParaRPr lang="en-US" sz="1200" dirty="0">
                         <a:latin typeface="Calibri" charset="0"/>
@@ -11314,7 +10034,7 @@
                           <a:ea typeface="Calibri" pitchFamily="34" charset="-122"/>
                           <a:cs typeface="Calibri" pitchFamily="34" charset="-120"/>
                         </a:rPr>
-                        <a:t>Demo run on guardian.com, this deck, README.md</a:t>
+                        <a:t>Demo run on guardian.com, this deck</a:t>
                       </a:r>
                       <a:endParaRPr lang="en-US" sz="1200" dirty="0">
                         <a:latin typeface="Calibri" charset="0"/>
@@ -15432,7 +14152,7 @@
               <a:buNone/>
             </a:pPr>
             <a:r>
-              <a:rPr lang="en-US" sz="1400" b="1" dirty="0">
+              <a:rPr lang="en-US" sz="1400" b="1" dirty="0" err="1">
                 <a:solidFill>
                   <a:srgbClr val="0F172A"/>
                 </a:solidFill>
@@ -15440,7 +14160,18 @@
                 <a:ea typeface="Consolas" pitchFamily="34" charset="-122"/>
                 <a:cs typeface="Consolas" pitchFamily="34" charset="-120"/>
               </a:rPr>
-              <a:t>__init__  /  log_entry</a:t>
+              <a:t>log_entry</a:t>
+            </a:r>
+            <a:r>
+              <a:rPr lang="en-US" sz="1400" b="1" dirty="0">
+                <a:solidFill>
+                  <a:srgbClr val="0F172A"/>
+                </a:solidFill>
+                <a:latin typeface="Consolas" pitchFamily="34" charset="0"/>
+                <a:ea typeface="Consolas" pitchFamily="34" charset="-122"/>
+                <a:cs typeface="Consolas" pitchFamily="34" charset="-120"/>
+              </a:rPr>
+              <a:t> (self, entry)</a:t>
             </a:r>
             <a:endParaRPr lang="en-US" sz="1400" dirty="0"/>
           </a:p>
@@ -15608,7 +14339,7 @@
               <a:buNone/>
             </a:pPr>
             <a:r>
-              <a:rPr lang="en-US" sz="1400" b="1" dirty="0">
+              <a:rPr lang="en-US" sz="1400" b="1" dirty="0" err="1">
                 <a:solidFill>
                   <a:srgbClr val="0F172A"/>
                 </a:solidFill>
@@ -15616,7 +14347,18 @@
                 <a:ea typeface="Consolas" pitchFamily="34" charset="-122"/>
                 <a:cs typeface="Consolas" pitchFamily="34" charset="-120"/>
               </a:rPr>
-              <a:t>parse_robots_txt(logger)</a:t>
+              <a:t>parse_robots_txt</a:t>
+            </a:r>
+            <a:r>
+              <a:rPr lang="en-US" sz="1400" b="1" dirty="0">
+                <a:solidFill>
+                  <a:srgbClr val="0F172A"/>
+                </a:solidFill>
+                <a:latin typeface="Consolas" pitchFamily="34" charset="0"/>
+                <a:ea typeface="Consolas" pitchFamily="34" charset="-122"/>
+                <a:cs typeface="Consolas" pitchFamily="34" charset="-120"/>
+              </a:rPr>
+              <a:t>(self, logger)</a:t>
             </a:r>
             <a:endParaRPr lang="en-US" sz="1400" dirty="0"/>
           </a:p>
@@ -16026,822 +14768,6 @@
 </file>
 
 <file path=ppt/slides/slide8.xml><?xml version="1.0" encoding="utf-8"?>
-<p:sld xmlns:a="http://schemas.openxmlformats.org/drawingml/2006/main" xmlns:r="http://schemas.openxmlformats.org/officeDocument/2006/relationships" xmlns:p="http://schemas.openxmlformats.org/presentationml/2006/main">
-  <p:cSld name="Slide 8">
-    <p:bg>
-      <p:bgPr>
-        <a:solidFill>
-          <a:srgbClr val="FFFFFF"/>
-        </a:solidFill>
-        <a:effectLst/>
-      </p:bgPr>
-    </p:bg>
-    <p:spTree>
-      <p:nvGrpSpPr>
-        <p:cNvPr id="1" name=""/>
-        <p:cNvGrpSpPr/>
-        <p:nvPr/>
-      </p:nvGrpSpPr>
-      <p:grpSpPr>
-        <a:xfrm>
-          <a:off x="0" y="0"/>
-          <a:ext cx="0" cy="0"/>
-          <a:chOff x="0" y="0"/>
-          <a:chExt cx="0" cy="0"/>
-        </a:xfrm>
-      </p:grpSpPr>
-      <p:sp>
-        <p:nvSpPr>
-          <p:cNvPr id="2" name="Shape 0"/>
-          <p:cNvSpPr/>
-          <p:nvPr/>
-        </p:nvSpPr>
-        <p:spPr>
-          <a:xfrm>
-            <a:off x="457200" y="502920"/>
-            <a:ext cx="164592" cy="164592"/>
-          </a:xfrm>
-          <a:prstGeom prst="ellipse">
-            <a:avLst/>
-          </a:prstGeom>
-          <a:solidFill>
-            <a:srgbClr val="14B8A6"/>
-          </a:solidFill>
-          <a:ln/>
-        </p:spPr>
-        <p:txBody>
-          <a:bodyPr/>
-          <a:lstStyle/>
-          <a:p>
-            <a:endParaRPr lang="en-US"/>
-          </a:p>
-        </p:txBody>
-      </p:sp>
-      <p:sp>
-        <p:nvSpPr>
-          <p:cNvPr id="3" name="Text 1"/>
-          <p:cNvSpPr/>
-          <p:nvPr/>
-        </p:nvSpPr>
-        <p:spPr>
-          <a:xfrm>
-            <a:off x="713232" y="411480"/>
-            <a:ext cx="5486400" cy="320040"/>
-          </a:xfrm>
-          <a:prstGeom prst="rect">
-            <a:avLst/>
-          </a:prstGeom>
-          <a:noFill/>
-          <a:ln/>
-        </p:spPr>
-        <p:txBody>
-          <a:bodyPr wrap="square" lIns="0" tIns="0" rIns="0" bIns="0" rtlCol="0" anchor="ctr"/>
-          <a:lstStyle/>
-          <a:p>
-            <a:pPr marL="0" indent="0">
-              <a:buNone/>
-            </a:pPr>
-            <a:r>
-              <a:rPr lang="en-US" sz="1000" b="1" kern="0" spc="400" dirty="0">
-                <a:solidFill>
-                  <a:srgbClr val="64748B"/>
-                </a:solidFill>
-                <a:latin typeface="Calibri" pitchFamily="34" charset="0"/>
-                <a:ea typeface="Calibri" pitchFamily="34" charset="-122"/>
-                <a:cs typeface="Calibri" pitchFamily="34" charset="-120"/>
-              </a:rPr>
-              <a:t>PAGEHARVESTER  ·  GROUP 7</a:t>
-            </a:r>
-            <a:endParaRPr lang="en-US" sz="1000" dirty="0"/>
-          </a:p>
-        </p:txBody>
-      </p:sp>
-      <p:sp>
-        <p:nvSpPr>
-          <p:cNvPr id="4" name="Text 2"/>
-          <p:cNvSpPr/>
-          <p:nvPr/>
-        </p:nvSpPr>
-        <p:spPr>
-          <a:xfrm>
-            <a:off x="457200" y="822960"/>
-            <a:ext cx="11247120" cy="731520"/>
-          </a:xfrm>
-          <a:prstGeom prst="rect">
-            <a:avLst/>
-          </a:prstGeom>
-          <a:noFill/>
-          <a:ln/>
-        </p:spPr>
-        <p:txBody>
-          <a:bodyPr wrap="square" lIns="0" tIns="0" rIns="0" bIns="0" rtlCol="0" anchor="ctr"/>
-          <a:lstStyle/>
-          <a:p>
-            <a:pPr marL="0" indent="0">
-              <a:buNone/>
-            </a:pPr>
-            <a:r>
-              <a:rPr lang="en-US" sz="3200" b="1" dirty="0">
-                <a:solidFill>
-                  <a:srgbClr val="0F172A"/>
-                </a:solidFill>
-                <a:latin typeface="Georgia" pitchFamily="34" charset="0"/>
-                <a:ea typeface="Georgia" pitchFamily="34" charset="-122"/>
-                <a:cs typeface="Georgia" pitchFamily="34" charset="-120"/>
-              </a:rPr>
-              <a:t>Q1 — Identifying &amp; Avoiding Crawler Traps</a:t>
-            </a:r>
-            <a:endParaRPr lang="en-US" sz="3200" dirty="0"/>
-          </a:p>
-        </p:txBody>
-      </p:sp>
-      <p:sp>
-        <p:nvSpPr>
-          <p:cNvPr id="5" name="Text 3"/>
-          <p:cNvSpPr/>
-          <p:nvPr/>
-        </p:nvSpPr>
-        <p:spPr>
-          <a:xfrm>
-            <a:off x="11247120" y="6446520"/>
-            <a:ext cx="731520" cy="274320"/>
-          </a:xfrm>
-          <a:prstGeom prst="rect">
-            <a:avLst/>
-          </a:prstGeom>
-          <a:noFill/>
-          <a:ln/>
-        </p:spPr>
-        <p:txBody>
-          <a:bodyPr wrap="square" lIns="0" tIns="0" rIns="0" bIns="0" rtlCol="0" anchor="ctr"/>
-          <a:lstStyle/>
-          <a:p>
-            <a:pPr marL="0" indent="0" algn="r">
-              <a:buNone/>
-            </a:pPr>
-            <a:r>
-              <a:rPr lang="en-US" sz="900" dirty="0">
-                <a:solidFill>
-                  <a:srgbClr val="94A3B8"/>
-                </a:solidFill>
-                <a:latin typeface="Calibri" pitchFamily="34" charset="0"/>
-                <a:ea typeface="Calibri" pitchFamily="34" charset="-122"/>
-                <a:cs typeface="Calibri" pitchFamily="34" charset="-120"/>
-              </a:rPr>
-              <a:t>8 / 14</a:t>
-            </a:r>
-            <a:endParaRPr lang="en-US" sz="900" dirty="0"/>
-          </a:p>
-        </p:txBody>
-      </p:sp>
-      <p:sp>
-        <p:nvSpPr>
-          <p:cNvPr id="6" name="Text 4"/>
-          <p:cNvSpPr/>
-          <p:nvPr/>
-        </p:nvSpPr>
-        <p:spPr>
-          <a:xfrm>
-            <a:off x="457200" y="6446520"/>
-            <a:ext cx="3657600" cy="274320"/>
-          </a:xfrm>
-          <a:prstGeom prst="rect">
-            <a:avLst/>
-          </a:prstGeom>
-          <a:noFill/>
-          <a:ln/>
-        </p:spPr>
-        <p:txBody>
-          <a:bodyPr wrap="square" lIns="0" tIns="0" rIns="0" bIns="0" rtlCol="0" anchor="ctr"/>
-          <a:lstStyle/>
-          <a:p>
-            <a:pPr marL="0" indent="0">
-              <a:buNone/>
-            </a:pPr>
-            <a:r>
-              <a:rPr lang="en-US" sz="900" dirty="0">
-                <a:solidFill>
-                  <a:srgbClr val="94A3B8"/>
-                </a:solidFill>
-                <a:latin typeface="Calibri" pitchFamily="34" charset="0"/>
-                <a:ea typeface="Calibri" pitchFamily="34" charset="-122"/>
-                <a:cs typeface="Calibri" pitchFamily="34" charset="-120"/>
-              </a:rPr>
-              <a:t>CS 494/493</a:t>
-            </a:r>
-            <a:endParaRPr lang="en-US" sz="900" dirty="0"/>
-          </a:p>
-        </p:txBody>
-      </p:sp>
-      <p:sp>
-        <p:nvSpPr>
-          <p:cNvPr id="7" name="Shape 5"/>
-          <p:cNvSpPr/>
-          <p:nvPr/>
-        </p:nvSpPr>
-        <p:spPr>
-          <a:xfrm>
-            <a:off x="457200" y="1691640"/>
-            <a:ext cx="11247120" cy="868680"/>
-          </a:xfrm>
-          <a:prstGeom prst="rect">
-            <a:avLst/>
-          </a:prstGeom>
-          <a:solidFill>
-            <a:srgbClr val="F1F5F9"/>
-          </a:solidFill>
-          <a:ln/>
-        </p:spPr>
-        <p:txBody>
-          <a:bodyPr/>
-          <a:lstStyle/>
-          <a:p>
-            <a:endParaRPr lang="en-US"/>
-          </a:p>
-        </p:txBody>
-      </p:sp>
-      <p:sp>
-        <p:nvSpPr>
-          <p:cNvPr id="8" name="Shape 6"/>
-          <p:cNvSpPr/>
-          <p:nvPr/>
-        </p:nvSpPr>
-        <p:spPr>
-          <a:xfrm>
-            <a:off x="457200" y="1691640"/>
-            <a:ext cx="73152" cy="868680"/>
-          </a:xfrm>
-          <a:prstGeom prst="rect">
-            <a:avLst/>
-          </a:prstGeom>
-          <a:solidFill>
-            <a:srgbClr val="D97706"/>
-          </a:solidFill>
-          <a:ln/>
-        </p:spPr>
-        <p:txBody>
-          <a:bodyPr/>
-          <a:lstStyle/>
-          <a:p>
-            <a:endParaRPr lang="en-US"/>
-          </a:p>
-        </p:txBody>
-      </p:sp>
-      <p:sp>
-        <p:nvSpPr>
-          <p:cNvPr id="9" name="Text 7"/>
-          <p:cNvSpPr/>
-          <p:nvPr/>
-        </p:nvSpPr>
-        <p:spPr>
-          <a:xfrm>
-            <a:off x="713232" y="1783080"/>
-            <a:ext cx="10972800" cy="274320"/>
-          </a:xfrm>
-          <a:prstGeom prst="rect">
-            <a:avLst/>
-          </a:prstGeom>
-          <a:noFill/>
-          <a:ln/>
-        </p:spPr>
-        <p:txBody>
-          <a:bodyPr wrap="square" lIns="0" tIns="0" rIns="0" bIns="0" rtlCol="0" anchor="ctr"/>
-          <a:lstStyle/>
-          <a:p>
-            <a:pPr marL="0" indent="0">
-              <a:buNone/>
-            </a:pPr>
-            <a:r>
-              <a:rPr lang="en-US" sz="1000" b="1" kern="0" spc="400" dirty="0">
-                <a:solidFill>
-                  <a:srgbClr val="D97706"/>
-                </a:solidFill>
-                <a:latin typeface="Calibri" pitchFamily="34" charset="0"/>
-                <a:ea typeface="Calibri" pitchFamily="34" charset="-122"/>
-                <a:cs typeface="Calibri" pitchFamily="34" charset="-120"/>
-              </a:rPr>
-              <a:t>WHAT IS A CRAWLER TRAP?</a:t>
-            </a:r>
-            <a:endParaRPr lang="en-US" sz="1000" dirty="0"/>
-          </a:p>
-        </p:txBody>
-      </p:sp>
-      <p:sp>
-        <p:nvSpPr>
-          <p:cNvPr id="10" name="Text 8"/>
-          <p:cNvSpPr/>
-          <p:nvPr/>
-        </p:nvSpPr>
-        <p:spPr>
-          <a:xfrm>
-            <a:off x="713232" y="2057400"/>
-            <a:ext cx="10972800" cy="457200"/>
-          </a:xfrm>
-          <a:prstGeom prst="rect">
-            <a:avLst/>
-          </a:prstGeom>
-          <a:noFill/>
-          <a:ln/>
-        </p:spPr>
-        <p:txBody>
-          <a:bodyPr wrap="square" lIns="0" tIns="0" rIns="0" bIns="0" rtlCol="0" anchor="ctr"/>
-          <a:lstStyle/>
-          <a:p>
-            <a:pPr marL="0" indent="0">
-              <a:buNone/>
-            </a:pPr>
-            <a:r>
-              <a:rPr lang="en-US" sz="1200" dirty="0">
-                <a:solidFill>
-                  <a:srgbClr val="1E293B"/>
-                </a:solidFill>
-                <a:latin typeface="Calibri" pitchFamily="34" charset="0"/>
-                <a:ea typeface="Calibri" pitchFamily="34" charset="-122"/>
-                <a:cs typeface="Calibri" pitchFamily="34" charset="-120"/>
-              </a:rPr>
-              <a:t>URL patterns that produce unbounded or near-infinite request chains — calendar pages, dynamic query parameters, recursive directory mirrors, or session-token URLs that change on every visit.</a:t>
-            </a:r>
-            <a:endParaRPr lang="en-US" sz="1200" dirty="0"/>
-          </a:p>
-        </p:txBody>
-      </p:sp>
-      <p:sp>
-        <p:nvSpPr>
-          <p:cNvPr id="11" name="Shape 9"/>
-          <p:cNvSpPr/>
-          <p:nvPr/>
-        </p:nvSpPr>
-        <p:spPr>
-          <a:xfrm>
-            <a:off x="457200" y="2788920"/>
-            <a:ext cx="5532120" cy="3520440"/>
-          </a:xfrm>
-          <a:prstGeom prst="rect">
-            <a:avLst/>
-          </a:prstGeom>
-          <a:solidFill>
-            <a:srgbClr val="FFFFFF"/>
-          </a:solidFill>
-          <a:ln w="12700">
-            <a:solidFill>
-              <a:srgbClr val="E2E8F0"/>
-            </a:solidFill>
-            <a:prstDash val="solid"/>
-          </a:ln>
-        </p:spPr>
-        <p:txBody>
-          <a:bodyPr/>
-          <a:lstStyle/>
-          <a:p>
-            <a:endParaRPr lang="en-US"/>
-          </a:p>
-        </p:txBody>
-      </p:sp>
-      <p:sp>
-        <p:nvSpPr>
-          <p:cNvPr id="12" name="Text 10"/>
-          <p:cNvSpPr/>
-          <p:nvPr/>
-        </p:nvSpPr>
-        <p:spPr>
-          <a:xfrm>
-            <a:off x="640080" y="2971800"/>
-            <a:ext cx="4572000" cy="274320"/>
-          </a:xfrm>
-          <a:prstGeom prst="rect">
-            <a:avLst/>
-          </a:prstGeom>
-          <a:noFill/>
-          <a:ln/>
-        </p:spPr>
-        <p:txBody>
-          <a:bodyPr wrap="square" lIns="0" tIns="0" rIns="0" bIns="0" rtlCol="0" anchor="ctr"/>
-          <a:lstStyle/>
-          <a:p>
-            <a:pPr marL="0" indent="0">
-              <a:buNone/>
-            </a:pPr>
-            <a:r>
-              <a:rPr lang="en-US" sz="1000" b="1" kern="0" spc="400" dirty="0">
-                <a:solidFill>
-                  <a:srgbClr val="14B8A6"/>
-                </a:solidFill>
-                <a:latin typeface="Calibri" pitchFamily="34" charset="0"/>
-                <a:ea typeface="Calibri" pitchFamily="34" charset="-122"/>
-                <a:cs typeface="Calibri" pitchFamily="34" charset="-120"/>
-              </a:rPr>
-              <a:t>HOW WE IDENTIFY</a:t>
-            </a:r>
-            <a:endParaRPr lang="en-US" sz="1000" dirty="0"/>
-          </a:p>
-        </p:txBody>
-      </p:sp>
-      <p:sp>
-        <p:nvSpPr>
-          <p:cNvPr id="13" name="Text 11"/>
-          <p:cNvSpPr/>
-          <p:nvPr/>
-        </p:nvSpPr>
-        <p:spPr>
-          <a:xfrm>
-            <a:off x="640080" y="3246120"/>
-            <a:ext cx="5120640" cy="457200"/>
-          </a:xfrm>
-          <a:prstGeom prst="rect">
-            <a:avLst/>
-          </a:prstGeom>
-          <a:noFill/>
-          <a:ln/>
-        </p:spPr>
-        <p:txBody>
-          <a:bodyPr wrap="square" lIns="0" tIns="0" rIns="0" bIns="0" rtlCol="0" anchor="ctr"/>
-          <a:lstStyle/>
-          <a:p>
-            <a:pPr marL="0" indent="0">
-              <a:buNone/>
-            </a:pPr>
-            <a:r>
-              <a:rPr lang="en-US" sz="1800" b="1" dirty="0">
-                <a:solidFill>
-                  <a:srgbClr val="0F172A"/>
-                </a:solidFill>
-                <a:latin typeface="Georgia" pitchFamily="34" charset="0"/>
-                <a:ea typeface="Georgia" pitchFamily="34" charset="-122"/>
-                <a:cs typeface="Georgia" pitchFamily="34" charset="-120"/>
-              </a:rPr>
-              <a:t>Detection signals</a:t>
-            </a:r>
-            <a:endParaRPr lang="en-US" sz="1800" dirty="0"/>
-          </a:p>
-        </p:txBody>
-      </p:sp>
-      <p:sp>
-        <p:nvSpPr>
-          <p:cNvPr id="14" name="Text 12"/>
-          <p:cNvSpPr/>
-          <p:nvPr/>
-        </p:nvSpPr>
-        <p:spPr>
-          <a:xfrm>
-            <a:off x="640080" y="3794760"/>
-            <a:ext cx="5120640" cy="2377440"/>
-          </a:xfrm>
-          <a:prstGeom prst="rect">
-            <a:avLst/>
-          </a:prstGeom>
-          <a:noFill/>
-          <a:ln/>
-        </p:spPr>
-        <p:txBody>
-          <a:bodyPr wrap="square" lIns="0" tIns="0" rIns="0" bIns="0" rtlCol="0" anchor="ctr"/>
-          <a:lstStyle/>
-          <a:p>
-            <a:pPr marL="342900" indent="-342900">
-              <a:spcAft>
-                <a:spcPts val="600"/>
-              </a:spcAft>
-              <a:buSzPct val="100000"/>
-              <a:buChar char="■"/>
-            </a:pPr>
-            <a:r>
-              <a:rPr lang="en-US" sz="1200" dirty="0">
-                <a:solidFill>
-                  <a:srgbClr val="1E293B"/>
-                </a:solidFill>
-                <a:latin typeface="Calibri" pitchFamily="34" charset="0"/>
-                <a:ea typeface="Calibri" pitchFamily="34" charset="-122"/>
-                <a:cs typeface="Calibri" pitchFamily="34" charset="-120"/>
-              </a:rPr>
-              <a:t>URL depth growing without new domain content</a:t>
-            </a:r>
-            <a:endParaRPr lang="en-US" sz="1200" dirty="0"/>
-          </a:p>
-          <a:p>
-            <a:pPr marL="342900" indent="-342900">
-              <a:spcAft>
-                <a:spcPts val="600"/>
-              </a:spcAft>
-              <a:buSzPct val="100000"/>
-              <a:buChar char="■"/>
-            </a:pPr>
-            <a:r>
-              <a:rPr lang="en-US" sz="1200" dirty="0">
-                <a:solidFill>
-                  <a:srgbClr val="1E293B"/>
-                </a:solidFill>
-                <a:latin typeface="Calibri" pitchFamily="34" charset="0"/>
-                <a:ea typeface="Calibri" pitchFamily="34" charset="-122"/>
-                <a:cs typeface="Calibri" pitchFamily="34" charset="-120"/>
-              </a:rPr>
-              <a:t>Repeating path segments (e.g. /a/b/a/b/a)</a:t>
-            </a:r>
-            <a:endParaRPr lang="en-US" sz="1200" dirty="0"/>
-          </a:p>
-          <a:p>
-            <a:pPr marL="342900" indent="-342900">
-              <a:spcAft>
-                <a:spcPts val="600"/>
-              </a:spcAft>
-              <a:buSzPct val="100000"/>
-              <a:buChar char="■"/>
-            </a:pPr>
-            <a:r>
-              <a:rPr lang="en-US" sz="1200" dirty="0">
-                <a:solidFill>
-                  <a:srgbClr val="1E293B"/>
-                </a:solidFill>
-                <a:latin typeface="Calibri" pitchFamily="34" charset="0"/>
-                <a:ea typeface="Calibri" pitchFamily="34" charset="-122"/>
-                <a:cs typeface="Calibri" pitchFamily="34" charset="-120"/>
-              </a:rPr>
-              <a:t>Calendar / pagination params advancing forever</a:t>
-            </a:r>
-            <a:endParaRPr lang="en-US" sz="1200" dirty="0"/>
-          </a:p>
-          <a:p>
-            <a:pPr marL="342900" indent="-342900">
-              <a:spcAft>
-                <a:spcPts val="600"/>
-              </a:spcAft>
-              <a:buSzPct val="100000"/>
-              <a:buChar char="■"/>
-            </a:pPr>
-            <a:r>
-              <a:rPr lang="en-US" sz="1200" dirty="0">
-                <a:solidFill>
-                  <a:srgbClr val="1E293B"/>
-                </a:solidFill>
-                <a:latin typeface="Calibri" pitchFamily="34" charset="0"/>
-                <a:ea typeface="Calibri" pitchFamily="34" charset="-122"/>
-                <a:cs typeface="Calibri" pitchFamily="34" charset="-120"/>
-              </a:rPr>
-              <a:t>Session IDs that mutate per request</a:t>
-            </a:r>
-            <a:endParaRPr lang="en-US" sz="1200" dirty="0"/>
-          </a:p>
-          <a:p>
-            <a:pPr marL="342900" indent="-342900">
-              <a:buSzPct val="100000"/>
-              <a:buChar char="■"/>
-            </a:pPr>
-            <a:r>
-              <a:rPr lang="en-US" sz="1200" dirty="0">
-                <a:solidFill>
-                  <a:srgbClr val="1E293B"/>
-                </a:solidFill>
-                <a:latin typeface="Calibri" pitchFamily="34" charset="0"/>
-                <a:ea typeface="Calibri" pitchFamily="34" charset="-122"/>
-                <a:cs typeface="Calibri" pitchFamily="34" charset="-120"/>
-              </a:rPr>
-              <a:t>Response size patterns (templated, near-identical content)</a:t>
-            </a:r>
-            <a:endParaRPr lang="en-US" sz="1200" dirty="0"/>
-          </a:p>
-        </p:txBody>
-      </p:sp>
-      <p:sp>
-        <p:nvSpPr>
-          <p:cNvPr id="15" name="Shape 13"/>
-          <p:cNvSpPr/>
-          <p:nvPr/>
-        </p:nvSpPr>
-        <p:spPr>
-          <a:xfrm>
-            <a:off x="6199632" y="2788920"/>
-            <a:ext cx="5532120" cy="3520440"/>
-          </a:xfrm>
-          <a:prstGeom prst="rect">
-            <a:avLst/>
-          </a:prstGeom>
-          <a:solidFill>
-            <a:srgbClr val="FFFFFF"/>
-          </a:solidFill>
-          <a:ln w="12700">
-            <a:solidFill>
-              <a:srgbClr val="E2E8F0"/>
-            </a:solidFill>
-            <a:prstDash val="solid"/>
-          </a:ln>
-        </p:spPr>
-        <p:txBody>
-          <a:bodyPr/>
-          <a:lstStyle/>
-          <a:p>
-            <a:endParaRPr lang="en-US"/>
-          </a:p>
-        </p:txBody>
-      </p:sp>
-      <p:sp>
-        <p:nvSpPr>
-          <p:cNvPr id="16" name="Text 14"/>
-          <p:cNvSpPr/>
-          <p:nvPr/>
-        </p:nvSpPr>
-        <p:spPr>
-          <a:xfrm>
-            <a:off x="6382512" y="2971800"/>
-            <a:ext cx="5029200" cy="274320"/>
-          </a:xfrm>
-          <a:prstGeom prst="rect">
-            <a:avLst/>
-          </a:prstGeom>
-          <a:noFill/>
-          <a:ln/>
-        </p:spPr>
-        <p:txBody>
-          <a:bodyPr wrap="square" lIns="0" tIns="0" rIns="0" bIns="0" rtlCol="0" anchor="ctr"/>
-          <a:lstStyle/>
-          <a:p>
-            <a:pPr marL="0" indent="0">
-              <a:buNone/>
-            </a:pPr>
-            <a:r>
-              <a:rPr lang="en-US" sz="1000" b="1" kern="0" spc="400" dirty="0">
-                <a:solidFill>
-                  <a:srgbClr val="14B8A6"/>
-                </a:solidFill>
-                <a:latin typeface="Calibri" pitchFamily="34" charset="0"/>
-                <a:ea typeface="Calibri" pitchFamily="34" charset="-122"/>
-                <a:cs typeface="Calibri" pitchFamily="34" charset="-120"/>
-              </a:rPr>
-              <a:t>HOW PAGEHARVESTER AVOIDS THEM</a:t>
-            </a:r>
-            <a:endParaRPr lang="en-US" sz="1000" dirty="0"/>
-          </a:p>
-        </p:txBody>
-      </p:sp>
-      <p:sp>
-        <p:nvSpPr>
-          <p:cNvPr id="17" name="Text 15"/>
-          <p:cNvSpPr/>
-          <p:nvPr/>
-        </p:nvSpPr>
-        <p:spPr>
-          <a:xfrm>
-            <a:off x="6382512" y="3246120"/>
-            <a:ext cx="5029200" cy="457200"/>
-          </a:xfrm>
-          <a:prstGeom prst="rect">
-            <a:avLst/>
-          </a:prstGeom>
-          <a:noFill/>
-          <a:ln/>
-        </p:spPr>
-        <p:txBody>
-          <a:bodyPr wrap="square" lIns="0" tIns="0" rIns="0" bIns="0" rtlCol="0" anchor="ctr"/>
-          <a:lstStyle/>
-          <a:p>
-            <a:pPr marL="0" indent="0">
-              <a:buNone/>
-            </a:pPr>
-            <a:r>
-              <a:rPr lang="en-US" sz="1800" b="1" dirty="0">
-                <a:solidFill>
-                  <a:srgbClr val="0F172A"/>
-                </a:solidFill>
-                <a:latin typeface="Georgia" pitchFamily="34" charset="0"/>
-                <a:ea typeface="Georgia" pitchFamily="34" charset="-122"/>
-                <a:cs typeface="Georgia" pitchFamily="34" charset="-120"/>
-              </a:rPr>
-              <a:t>Built-in protections</a:t>
-            </a:r>
-            <a:endParaRPr lang="en-US" sz="1800" dirty="0"/>
-          </a:p>
-        </p:txBody>
-      </p:sp>
-      <p:sp>
-        <p:nvSpPr>
-          <p:cNvPr id="18" name="Text 16"/>
-          <p:cNvSpPr/>
-          <p:nvPr/>
-        </p:nvSpPr>
-        <p:spPr>
-          <a:xfrm>
-            <a:off x="6382512" y="3794760"/>
-            <a:ext cx="5029200" cy="2377440"/>
-          </a:xfrm>
-          <a:prstGeom prst="rect">
-            <a:avLst/>
-          </a:prstGeom>
-          <a:noFill/>
-          <a:ln/>
-        </p:spPr>
-        <p:txBody>
-          <a:bodyPr wrap="square" lIns="0" tIns="0" rIns="0" bIns="0" rtlCol="0" anchor="ctr"/>
-          <a:lstStyle/>
-          <a:p>
-            <a:pPr marL="342900" indent="-342900">
-              <a:spcAft>
-                <a:spcPts val="600"/>
-              </a:spcAft>
-              <a:buSzPct val="100000"/>
-              <a:buChar char="■"/>
-            </a:pPr>
-            <a:r>
-              <a:rPr lang="en-US" sz="1200" dirty="0">
-                <a:solidFill>
-                  <a:srgbClr val="1E293B"/>
-                </a:solidFill>
-                <a:latin typeface="Calibri" pitchFamily="34" charset="0"/>
-                <a:ea typeface="Calibri" pitchFamily="34" charset="-122"/>
-                <a:cs typeface="Calibri" pitchFamily="34" charset="-120"/>
-              </a:rPr>
-              <a:t>Sitemap-bounded URL set — we never extract links from downloaded HTML, so there is no recursive descent</a:t>
-            </a:r>
-            <a:endParaRPr lang="en-US" sz="1200" dirty="0"/>
-          </a:p>
-          <a:p>
-            <a:pPr marL="342900" indent="-342900">
-              <a:spcAft>
-                <a:spcPts val="600"/>
-              </a:spcAft>
-              <a:buSzPct val="100000"/>
-              <a:buChar char="■"/>
-            </a:pPr>
-            <a:r>
-              <a:rPr lang="en-US" sz="1200" dirty="0">
-                <a:solidFill>
-                  <a:srgbClr val="1E293B"/>
-                </a:solidFill>
-                <a:latin typeface="Calibri" pitchFamily="34" charset="0"/>
-                <a:ea typeface="Calibri" pitchFamily="34" charset="-122"/>
-                <a:cs typeface="Calibri" pitchFamily="34" charset="-120"/>
-              </a:rPr>
-              <a:t>Topic regex with word boundaries (\b…\b) prunes irrelevant URLs early</a:t>
-            </a:r>
-            <a:endParaRPr lang="en-US" sz="1200" dirty="0"/>
-          </a:p>
-          <a:p>
-            <a:pPr marL="342900" indent="-342900">
-              <a:spcAft>
-                <a:spcPts val="600"/>
-              </a:spcAft>
-              <a:buSzPct val="100000"/>
-              <a:buChar char="■"/>
-            </a:pPr>
-            <a:r>
-              <a:rPr lang="en-US" sz="1200" dirty="0">
-                <a:solidFill>
-                  <a:srgbClr val="1E293B"/>
-                </a:solidFill>
-                <a:latin typeface="Calibri" pitchFamily="34" charset="0"/>
-                <a:ea typeface="Calibri" pitchFamily="34" charset="-122"/>
-                <a:cs typeface="Calibri" pitchFamily="34" charset="-120"/>
-              </a:rPr>
-              <a:t>robots.txt enforcement via can_fetch() before every download</a:t>
-            </a:r>
-            <a:endParaRPr lang="en-US" sz="1200" dirty="0"/>
-          </a:p>
-          <a:p>
-            <a:pPr marL="342900" indent="-342900">
-              <a:spcAft>
-                <a:spcPts val="600"/>
-              </a:spcAft>
-              <a:buSzPct val="100000"/>
-              <a:buChar char="■"/>
-            </a:pPr>
-            <a:r>
-              <a:rPr lang="en-US" sz="1200" dirty="0">
-                <a:solidFill>
-                  <a:srgbClr val="1E293B"/>
-                </a:solidFill>
-                <a:latin typeface="Calibri" pitchFamily="34" charset="0"/>
-                <a:ea typeface="Calibri" pitchFamily="34" charset="-122"/>
-                <a:cs typeface="Calibri" pitchFamily="34" charset="-120"/>
-              </a:rPr>
-              <a:t>Single-pass workflow — sitemap → loc → fetch, with no link queue</a:t>
-            </a:r>
-            <a:endParaRPr lang="en-US" sz="1200" dirty="0"/>
-          </a:p>
-          <a:p>
-            <a:pPr marL="342900" indent="-342900">
-              <a:buSzPct val="100000"/>
-              <a:buChar char="■"/>
-            </a:pPr>
-            <a:r>
-              <a:rPr lang="en-US" sz="1200" dirty="0">
-                <a:solidFill>
-                  <a:srgbClr val="1E293B"/>
-                </a:solidFill>
-                <a:latin typeface="Calibri" pitchFamily="34" charset="0"/>
-                <a:ea typeface="Calibri" pitchFamily="34" charset="-122"/>
-                <a:cs typeface="Calibri" pitchFamily="34" charset="-120"/>
-              </a:rPr>
-              <a:t>5 s delay caps maximum request rate as a hard ceiling</a:t>
-            </a:r>
-            <a:endParaRPr lang="en-US" sz="1200" dirty="0"/>
-          </a:p>
-        </p:txBody>
-      </p:sp>
-    </p:spTree>
-  </p:cSld>
-  <p:clrMapOvr>
-    <a:masterClrMapping/>
-  </p:clrMapOvr>
-</p:sld>
-</file>
-
-<file path=ppt/slides/slide9.xml><?xml version="1.0" encoding="utf-8"?>
 <p:sld xmlns:a="http://schemas.openxmlformats.org/drawingml/2006/main" xmlns:r="http://schemas.openxmlformats.org/officeDocument/2006/relationships" xmlns:p="http://schemas.openxmlformats.org/presentationml/2006/main">
   <p:cSld name="Slide 9">
     <p:bg>
@@ -16965,7 +14891,7 @@
                 <a:ea typeface="Georgia" pitchFamily="34" charset="-122"/>
                 <a:cs typeface="Georgia" pitchFamily="34" charset="-120"/>
               </a:rPr>
-              <a:t>Q2 — Designing a Polite / Benign Crawler</a:t>
+              <a:t>Designing a Polite, Robust, Benign Crawler</a:t>
             </a:r>
             <a:endParaRPr lang="en-US" sz="3200" dirty="0"/>
           </a:p>
@@ -18396,6 +16322,1223 @@
               <a:t>            # write HTML to disk</a:t>
             </a:r>
             <a:endParaRPr lang="en-US" sz="1200" dirty="0"/>
+          </a:p>
+        </p:txBody>
+      </p:sp>
+    </p:spTree>
+  </p:cSld>
+  <p:clrMapOvr>
+    <a:masterClrMapping/>
+  </p:clrMapOvr>
+</p:sld>
+</file>
+
+<file path=ppt/slides/slide9.xml><?xml version="1.0" encoding="utf-8"?>
+<p:sld xmlns:a="http://schemas.openxmlformats.org/drawingml/2006/main" xmlns:r="http://schemas.openxmlformats.org/officeDocument/2006/relationships" xmlns:p="http://schemas.openxmlformats.org/presentationml/2006/main">
+  <p:cSld name="Slide 10">
+    <p:bg>
+      <p:bgPr>
+        <a:solidFill>
+          <a:srgbClr val="FFFFFF"/>
+        </a:solidFill>
+        <a:effectLst/>
+      </p:bgPr>
+    </p:bg>
+    <p:spTree>
+      <p:nvGrpSpPr>
+        <p:cNvPr id="1" name=""/>
+        <p:cNvGrpSpPr/>
+        <p:nvPr/>
+      </p:nvGrpSpPr>
+      <p:grpSpPr>
+        <a:xfrm>
+          <a:off x="0" y="0"/>
+          <a:ext cx="0" cy="0"/>
+          <a:chOff x="0" y="0"/>
+          <a:chExt cx="0" cy="0"/>
+        </a:xfrm>
+      </p:grpSpPr>
+      <p:sp>
+        <p:nvSpPr>
+          <p:cNvPr id="2" name="Shape 0"/>
+          <p:cNvSpPr/>
+          <p:nvPr/>
+        </p:nvSpPr>
+        <p:spPr>
+          <a:xfrm>
+            <a:off x="457200" y="502920"/>
+            <a:ext cx="164592" cy="164592"/>
+          </a:xfrm>
+          <a:prstGeom prst="ellipse">
+            <a:avLst/>
+          </a:prstGeom>
+          <a:solidFill>
+            <a:srgbClr val="14B8A6"/>
+          </a:solidFill>
+          <a:ln/>
+        </p:spPr>
+        <p:txBody>
+          <a:bodyPr/>
+          <a:lstStyle/>
+          <a:p>
+            <a:endParaRPr lang="en-US"/>
+          </a:p>
+        </p:txBody>
+      </p:sp>
+      <p:sp>
+        <p:nvSpPr>
+          <p:cNvPr id="3" name="Text 1"/>
+          <p:cNvSpPr/>
+          <p:nvPr/>
+        </p:nvSpPr>
+        <p:spPr>
+          <a:xfrm>
+            <a:off x="713232" y="411480"/>
+            <a:ext cx="5486400" cy="320040"/>
+          </a:xfrm>
+          <a:prstGeom prst="rect">
+            <a:avLst/>
+          </a:prstGeom>
+          <a:noFill/>
+          <a:ln/>
+        </p:spPr>
+        <p:txBody>
+          <a:bodyPr wrap="square" lIns="0" tIns="0" rIns="0" bIns="0" rtlCol="0" anchor="ctr"/>
+          <a:lstStyle/>
+          <a:p>
+            <a:pPr marL="0" indent="0">
+              <a:buNone/>
+            </a:pPr>
+            <a:r>
+              <a:rPr lang="en-US" sz="1000" b="1" kern="0" spc="400" dirty="0">
+                <a:solidFill>
+                  <a:srgbClr val="64748B"/>
+                </a:solidFill>
+                <a:latin typeface="Calibri" pitchFamily="34" charset="0"/>
+                <a:ea typeface="Calibri" pitchFamily="34" charset="-122"/>
+                <a:cs typeface="Calibri" pitchFamily="34" charset="-120"/>
+              </a:rPr>
+              <a:t>PAGEHARVESTER  ·  GROUP 7</a:t>
+            </a:r>
+            <a:endParaRPr lang="en-US" sz="1000" dirty="0"/>
+          </a:p>
+        </p:txBody>
+      </p:sp>
+      <p:sp>
+        <p:nvSpPr>
+          <p:cNvPr id="4" name="Text 2"/>
+          <p:cNvSpPr/>
+          <p:nvPr/>
+        </p:nvSpPr>
+        <p:spPr>
+          <a:xfrm>
+            <a:off x="457200" y="822960"/>
+            <a:ext cx="11247120" cy="731520"/>
+          </a:xfrm>
+          <a:prstGeom prst="rect">
+            <a:avLst/>
+          </a:prstGeom>
+          <a:noFill/>
+          <a:ln/>
+        </p:spPr>
+        <p:txBody>
+          <a:bodyPr wrap="square" lIns="0" tIns="0" rIns="0" bIns="0" rtlCol="0" anchor="ctr"/>
+          <a:lstStyle/>
+          <a:p>
+            <a:pPr marL="0" indent="0">
+              <a:buNone/>
+            </a:pPr>
+            <a:r>
+              <a:rPr lang="en-US" sz="3200" b="1" dirty="0">
+                <a:solidFill>
+                  <a:srgbClr val="0F172A"/>
+                </a:solidFill>
+                <a:latin typeface="Georgia" pitchFamily="34" charset="0"/>
+                <a:ea typeface="Georgia" pitchFamily="34" charset="-122"/>
+                <a:cs typeface="Georgia" pitchFamily="34" charset="-120"/>
+              </a:rPr>
+              <a:t>Implementing an Efficient Crawler</a:t>
+            </a:r>
+            <a:endParaRPr lang="en-US" sz="3200" dirty="0"/>
+          </a:p>
+        </p:txBody>
+      </p:sp>
+      <p:sp>
+        <p:nvSpPr>
+          <p:cNvPr id="5" name="Text 3"/>
+          <p:cNvSpPr/>
+          <p:nvPr/>
+        </p:nvSpPr>
+        <p:spPr>
+          <a:xfrm>
+            <a:off x="11247120" y="6446520"/>
+            <a:ext cx="731520" cy="274320"/>
+          </a:xfrm>
+          <a:prstGeom prst="rect">
+            <a:avLst/>
+          </a:prstGeom>
+          <a:noFill/>
+          <a:ln/>
+        </p:spPr>
+        <p:txBody>
+          <a:bodyPr wrap="square" lIns="0" tIns="0" rIns="0" bIns="0" rtlCol="0" anchor="ctr"/>
+          <a:lstStyle/>
+          <a:p>
+            <a:pPr marL="0" indent="0" algn="r">
+              <a:buNone/>
+            </a:pPr>
+            <a:r>
+              <a:rPr lang="en-US" sz="900" dirty="0">
+                <a:solidFill>
+                  <a:srgbClr val="94A3B8"/>
+                </a:solidFill>
+                <a:latin typeface="Calibri" pitchFamily="34" charset="0"/>
+                <a:ea typeface="Calibri" pitchFamily="34" charset="-122"/>
+                <a:cs typeface="Calibri" pitchFamily="34" charset="-120"/>
+              </a:rPr>
+              <a:t>10 / 14</a:t>
+            </a:r>
+            <a:endParaRPr lang="en-US" sz="900" dirty="0"/>
+          </a:p>
+        </p:txBody>
+      </p:sp>
+      <p:sp>
+        <p:nvSpPr>
+          <p:cNvPr id="6" name="Text 4"/>
+          <p:cNvSpPr/>
+          <p:nvPr/>
+        </p:nvSpPr>
+        <p:spPr>
+          <a:xfrm>
+            <a:off x="457200" y="6446520"/>
+            <a:ext cx="3657600" cy="274320"/>
+          </a:xfrm>
+          <a:prstGeom prst="rect">
+            <a:avLst/>
+          </a:prstGeom>
+          <a:noFill/>
+          <a:ln/>
+        </p:spPr>
+        <p:txBody>
+          <a:bodyPr wrap="square" lIns="0" tIns="0" rIns="0" bIns="0" rtlCol="0" anchor="ctr"/>
+          <a:lstStyle/>
+          <a:p>
+            <a:pPr marL="0" indent="0">
+              <a:buNone/>
+            </a:pPr>
+            <a:r>
+              <a:rPr lang="en-US" sz="900" dirty="0">
+                <a:solidFill>
+                  <a:srgbClr val="94A3B8"/>
+                </a:solidFill>
+                <a:latin typeface="Calibri" pitchFamily="34" charset="0"/>
+                <a:ea typeface="Calibri" pitchFamily="34" charset="-122"/>
+                <a:cs typeface="Calibri" pitchFamily="34" charset="-120"/>
+              </a:rPr>
+              <a:t>CS 494/493</a:t>
+            </a:r>
+            <a:endParaRPr lang="en-US" sz="900" dirty="0"/>
+          </a:p>
+        </p:txBody>
+      </p:sp>
+      <p:sp>
+        <p:nvSpPr>
+          <p:cNvPr id="7" name="Text 5"/>
+          <p:cNvSpPr/>
+          <p:nvPr/>
+        </p:nvSpPr>
+        <p:spPr>
+          <a:xfrm>
+            <a:off x="457200" y="1554480"/>
+            <a:ext cx="10972800" cy="365760"/>
+          </a:xfrm>
+          <a:prstGeom prst="rect">
+            <a:avLst/>
+          </a:prstGeom>
+          <a:noFill/>
+          <a:ln/>
+        </p:spPr>
+        <p:txBody>
+          <a:bodyPr wrap="square" lIns="0" tIns="0" rIns="0" bIns="0" rtlCol="0" anchor="ctr"/>
+          <a:lstStyle/>
+          <a:p>
+            <a:pPr marL="0" indent="0">
+              <a:buNone/>
+            </a:pPr>
+            <a:r>
+              <a:rPr lang="en-US" sz="1300" i="1" dirty="0">
+                <a:solidFill>
+                  <a:srgbClr val="64748B"/>
+                </a:solidFill>
+                <a:latin typeface="Calibri" pitchFamily="34" charset="0"/>
+                <a:ea typeface="Calibri" pitchFamily="34" charset="-122"/>
+                <a:cs typeface="Calibri" pitchFamily="34" charset="-120"/>
+              </a:rPr>
+              <a:t>Efficiency items in PageHarvester — cutting wasted requests, parses, and disk operations.</a:t>
+            </a:r>
+            <a:endParaRPr lang="en-US" sz="1300" dirty="0"/>
+          </a:p>
+        </p:txBody>
+      </p:sp>
+      <p:sp>
+        <p:nvSpPr>
+          <p:cNvPr id="8" name="Shape 6"/>
+          <p:cNvSpPr/>
+          <p:nvPr/>
+        </p:nvSpPr>
+        <p:spPr>
+          <a:xfrm>
+            <a:off x="444856" y="2103120"/>
+            <a:ext cx="3657600" cy="1828800"/>
+          </a:xfrm>
+          <a:prstGeom prst="rect">
+            <a:avLst/>
+          </a:prstGeom>
+          <a:solidFill>
+            <a:srgbClr val="FFFFFF"/>
+          </a:solidFill>
+          <a:ln w="12700">
+            <a:solidFill>
+              <a:srgbClr val="E2E8F0"/>
+            </a:solidFill>
+            <a:prstDash val="solid"/>
+          </a:ln>
+          <a:effectLst>
+            <a:outerShdw blurRad="101600" dist="25400" dir="5400000" algn="bl" rotWithShape="0">
+              <a:srgbClr val="0F172A">
+                <a:alpha val="8000"/>
+              </a:srgbClr>
+            </a:outerShdw>
+          </a:effectLst>
+        </p:spPr>
+        <p:txBody>
+          <a:bodyPr/>
+          <a:lstStyle/>
+          <a:p>
+            <a:endParaRPr lang="en-US"/>
+          </a:p>
+        </p:txBody>
+      </p:sp>
+      <p:sp>
+        <p:nvSpPr>
+          <p:cNvPr id="9" name="Text 7"/>
+          <p:cNvSpPr/>
+          <p:nvPr/>
+        </p:nvSpPr>
+        <p:spPr>
+          <a:xfrm>
+            <a:off x="719176" y="2286000"/>
+            <a:ext cx="1371600" cy="457200"/>
+          </a:xfrm>
+          <a:prstGeom prst="rect">
+            <a:avLst/>
+          </a:prstGeom>
+          <a:noFill/>
+          <a:ln/>
+        </p:spPr>
+        <p:txBody>
+          <a:bodyPr wrap="square" lIns="0" tIns="0" rIns="0" bIns="0" rtlCol="0" anchor="ctr"/>
+          <a:lstStyle/>
+          <a:p>
+            <a:pPr marL="0" indent="0">
+              <a:buNone/>
+            </a:pPr>
+            <a:r>
+              <a:rPr lang="en-US" sz="2200" b="1" dirty="0">
+                <a:solidFill>
+                  <a:srgbClr val="14B8A6"/>
+                </a:solidFill>
+                <a:latin typeface="Georgia" pitchFamily="34" charset="0"/>
+                <a:ea typeface="Georgia" pitchFamily="34" charset="-122"/>
+                <a:cs typeface="Georgia" pitchFamily="34" charset="-120"/>
+              </a:rPr>
+              <a:t>01</a:t>
+            </a:r>
+            <a:endParaRPr lang="en-US" sz="2200" dirty="0"/>
+          </a:p>
+        </p:txBody>
+      </p:sp>
+      <p:sp>
+        <p:nvSpPr>
+          <p:cNvPr id="10" name="Text 8"/>
+          <p:cNvSpPr/>
+          <p:nvPr/>
+        </p:nvSpPr>
+        <p:spPr>
+          <a:xfrm>
+            <a:off x="719176" y="2697480"/>
+            <a:ext cx="3108960" cy="365760"/>
+          </a:xfrm>
+          <a:prstGeom prst="rect">
+            <a:avLst/>
+          </a:prstGeom>
+          <a:noFill/>
+          <a:ln/>
+        </p:spPr>
+        <p:txBody>
+          <a:bodyPr wrap="square" lIns="0" tIns="0" rIns="0" bIns="0" rtlCol="0" anchor="ctr"/>
+          <a:lstStyle/>
+          <a:p>
+            <a:pPr marL="0" indent="0">
+              <a:buNone/>
+            </a:pPr>
+            <a:r>
+              <a:rPr lang="en-US" sz="1300" b="1" dirty="0">
+                <a:solidFill>
+                  <a:srgbClr val="0F172A"/>
+                </a:solidFill>
+                <a:latin typeface="Calibri" pitchFamily="34" charset="0"/>
+                <a:ea typeface="Calibri" pitchFamily="34" charset="-122"/>
+                <a:cs typeface="Calibri" pitchFamily="34" charset="-120"/>
+              </a:rPr>
+              <a:t>Sitemap-first discovery</a:t>
+            </a:r>
+            <a:endParaRPr lang="en-US" sz="1300" dirty="0"/>
+          </a:p>
+        </p:txBody>
+      </p:sp>
+      <p:sp>
+        <p:nvSpPr>
+          <p:cNvPr id="11" name="Text 9"/>
+          <p:cNvSpPr/>
+          <p:nvPr/>
+        </p:nvSpPr>
+        <p:spPr>
+          <a:xfrm>
+            <a:off x="719176" y="3063240"/>
+            <a:ext cx="3108960" cy="777240"/>
+          </a:xfrm>
+          <a:prstGeom prst="rect">
+            <a:avLst/>
+          </a:prstGeom>
+          <a:noFill/>
+          <a:ln/>
+        </p:spPr>
+        <p:txBody>
+          <a:bodyPr wrap="square" lIns="0" tIns="0" rIns="0" bIns="0" rtlCol="0" anchor="ctr"/>
+          <a:lstStyle/>
+          <a:p>
+            <a:pPr marL="0" indent="0">
+              <a:buNone/>
+            </a:pPr>
+            <a:r>
+              <a:rPr lang="en-US" sz="1050" dirty="0">
+                <a:solidFill>
+                  <a:srgbClr val="1E293B"/>
+                </a:solidFill>
+                <a:latin typeface="Calibri" pitchFamily="34" charset="0"/>
+                <a:ea typeface="Calibri" pitchFamily="34" charset="-122"/>
+                <a:cs typeface="Calibri" pitchFamily="34" charset="-120"/>
+              </a:rPr>
+              <a:t>Eliminates the need to search through “unallowed” HTML parent files. </a:t>
+            </a:r>
+            <a:endParaRPr lang="en-US" sz="1050" dirty="0"/>
+          </a:p>
+        </p:txBody>
+      </p:sp>
+      <p:sp>
+        <p:nvSpPr>
+          <p:cNvPr id="12" name="Shape 10"/>
+          <p:cNvSpPr/>
+          <p:nvPr/>
+        </p:nvSpPr>
+        <p:spPr>
+          <a:xfrm>
+            <a:off x="4267048" y="2103120"/>
+            <a:ext cx="3657600" cy="1828800"/>
+          </a:xfrm>
+          <a:prstGeom prst="rect">
+            <a:avLst/>
+          </a:prstGeom>
+          <a:solidFill>
+            <a:srgbClr val="FFFFFF"/>
+          </a:solidFill>
+          <a:ln w="12700">
+            <a:solidFill>
+              <a:srgbClr val="E2E8F0"/>
+            </a:solidFill>
+            <a:prstDash val="solid"/>
+          </a:ln>
+          <a:effectLst>
+            <a:outerShdw blurRad="101600" dist="25400" dir="5400000" algn="bl" rotWithShape="0">
+              <a:srgbClr val="0F172A">
+                <a:alpha val="8000"/>
+              </a:srgbClr>
+            </a:outerShdw>
+          </a:effectLst>
+        </p:spPr>
+        <p:txBody>
+          <a:bodyPr/>
+          <a:lstStyle/>
+          <a:p>
+            <a:endParaRPr lang="en-US"/>
+          </a:p>
+        </p:txBody>
+      </p:sp>
+      <p:sp>
+        <p:nvSpPr>
+          <p:cNvPr id="13" name="Text 11"/>
+          <p:cNvSpPr/>
+          <p:nvPr/>
+        </p:nvSpPr>
+        <p:spPr>
+          <a:xfrm>
+            <a:off x="4541368" y="2286000"/>
+            <a:ext cx="1371600" cy="457200"/>
+          </a:xfrm>
+          <a:prstGeom prst="rect">
+            <a:avLst/>
+          </a:prstGeom>
+          <a:noFill/>
+          <a:ln/>
+        </p:spPr>
+        <p:txBody>
+          <a:bodyPr wrap="square" lIns="0" tIns="0" rIns="0" bIns="0" rtlCol="0" anchor="ctr"/>
+          <a:lstStyle/>
+          <a:p>
+            <a:pPr marL="0" indent="0">
+              <a:buNone/>
+            </a:pPr>
+            <a:r>
+              <a:rPr lang="en-US" sz="2200" b="1" dirty="0">
+                <a:solidFill>
+                  <a:srgbClr val="14B8A6"/>
+                </a:solidFill>
+                <a:latin typeface="Georgia" pitchFamily="34" charset="0"/>
+                <a:ea typeface="Georgia" pitchFamily="34" charset="-122"/>
+                <a:cs typeface="Georgia" pitchFamily="34" charset="-120"/>
+              </a:rPr>
+              <a:t>02</a:t>
+            </a:r>
+            <a:endParaRPr lang="en-US" sz="2200" dirty="0"/>
+          </a:p>
+        </p:txBody>
+      </p:sp>
+      <p:sp>
+        <p:nvSpPr>
+          <p:cNvPr id="14" name="Text 12"/>
+          <p:cNvSpPr/>
+          <p:nvPr/>
+        </p:nvSpPr>
+        <p:spPr>
+          <a:xfrm>
+            <a:off x="4541368" y="2697480"/>
+            <a:ext cx="3108960" cy="365760"/>
+          </a:xfrm>
+          <a:prstGeom prst="rect">
+            <a:avLst/>
+          </a:prstGeom>
+          <a:noFill/>
+          <a:ln/>
+        </p:spPr>
+        <p:txBody>
+          <a:bodyPr wrap="square" lIns="0" tIns="0" rIns="0" bIns="0" rtlCol="0" anchor="ctr"/>
+          <a:lstStyle/>
+          <a:p>
+            <a:pPr marL="0" indent="0">
+              <a:buNone/>
+            </a:pPr>
+            <a:r>
+              <a:rPr lang="en-US" sz="1300" b="1" dirty="0">
+                <a:solidFill>
+                  <a:srgbClr val="0F172A"/>
+                </a:solidFill>
+                <a:latin typeface="Calibri" pitchFamily="34" charset="0"/>
+                <a:ea typeface="Calibri" pitchFamily="34" charset="-122"/>
+                <a:cs typeface="Calibri" pitchFamily="34" charset="-120"/>
+              </a:rPr>
+              <a:t>Topic filtering at sitemap level</a:t>
+            </a:r>
+            <a:endParaRPr lang="en-US" sz="1300" dirty="0"/>
+          </a:p>
+        </p:txBody>
+      </p:sp>
+      <p:sp>
+        <p:nvSpPr>
+          <p:cNvPr id="15" name="Text 13"/>
+          <p:cNvSpPr/>
+          <p:nvPr/>
+        </p:nvSpPr>
+        <p:spPr>
+          <a:xfrm>
+            <a:off x="4541368" y="3063240"/>
+            <a:ext cx="3108960" cy="777240"/>
+          </a:xfrm>
+          <a:prstGeom prst="rect">
+            <a:avLst/>
+          </a:prstGeom>
+          <a:noFill/>
+          <a:ln/>
+        </p:spPr>
+        <p:txBody>
+          <a:bodyPr wrap="square" lIns="0" tIns="0" rIns="0" bIns="0" rtlCol="0" anchor="ctr"/>
+          <a:lstStyle/>
+          <a:p>
+            <a:pPr marL="0" indent="0">
+              <a:buNone/>
+            </a:pPr>
+            <a:r>
+              <a:rPr lang="en-US" sz="1050" dirty="0">
+                <a:solidFill>
+                  <a:srgbClr val="1E293B"/>
+                </a:solidFill>
+                <a:latin typeface="Calibri" pitchFamily="34" charset="0"/>
+                <a:ea typeface="Calibri" pitchFamily="34" charset="-122"/>
+                <a:cs typeface="Calibri" pitchFamily="34" charset="-120"/>
+              </a:rPr>
+              <a:t>Regex used against raw sitemap XML to return relevant URLS, before fetching any page data. Rejecting numerous URLs prior to download.</a:t>
+            </a:r>
+            <a:endParaRPr lang="en-US" sz="1050" dirty="0"/>
+          </a:p>
+        </p:txBody>
+      </p:sp>
+      <p:sp>
+        <p:nvSpPr>
+          <p:cNvPr id="16" name="Shape 14"/>
+          <p:cNvSpPr/>
+          <p:nvPr/>
+        </p:nvSpPr>
+        <p:spPr>
+          <a:xfrm>
+            <a:off x="8089240" y="2103120"/>
+            <a:ext cx="3657600" cy="1828800"/>
+          </a:xfrm>
+          <a:prstGeom prst="rect">
+            <a:avLst/>
+          </a:prstGeom>
+          <a:solidFill>
+            <a:srgbClr val="FFFFFF"/>
+          </a:solidFill>
+          <a:ln w="12700">
+            <a:solidFill>
+              <a:srgbClr val="E2E8F0"/>
+            </a:solidFill>
+            <a:prstDash val="solid"/>
+          </a:ln>
+          <a:effectLst>
+            <a:outerShdw blurRad="101600" dist="25400" dir="5400000" algn="bl" rotWithShape="0">
+              <a:srgbClr val="0F172A">
+                <a:alpha val="8000"/>
+              </a:srgbClr>
+            </a:outerShdw>
+          </a:effectLst>
+        </p:spPr>
+        <p:txBody>
+          <a:bodyPr/>
+          <a:lstStyle/>
+          <a:p>
+            <a:endParaRPr lang="en-US"/>
+          </a:p>
+        </p:txBody>
+      </p:sp>
+      <p:sp>
+        <p:nvSpPr>
+          <p:cNvPr id="17" name="Text 15"/>
+          <p:cNvSpPr/>
+          <p:nvPr/>
+        </p:nvSpPr>
+        <p:spPr>
+          <a:xfrm>
+            <a:off x="8363560" y="2286000"/>
+            <a:ext cx="1371600" cy="457200"/>
+          </a:xfrm>
+          <a:prstGeom prst="rect">
+            <a:avLst/>
+          </a:prstGeom>
+          <a:noFill/>
+          <a:ln/>
+        </p:spPr>
+        <p:txBody>
+          <a:bodyPr wrap="square" lIns="0" tIns="0" rIns="0" bIns="0" rtlCol="0" anchor="ctr"/>
+          <a:lstStyle/>
+          <a:p>
+            <a:pPr marL="0" indent="0">
+              <a:buNone/>
+            </a:pPr>
+            <a:r>
+              <a:rPr lang="en-US" sz="2200" b="1" dirty="0">
+                <a:solidFill>
+                  <a:srgbClr val="14B8A6"/>
+                </a:solidFill>
+                <a:latin typeface="Georgia" pitchFamily="34" charset="0"/>
+                <a:ea typeface="Georgia" pitchFamily="34" charset="-122"/>
+                <a:cs typeface="Georgia" pitchFamily="34" charset="-120"/>
+              </a:rPr>
+              <a:t>03</a:t>
+            </a:r>
+            <a:endParaRPr lang="en-US" sz="2200" dirty="0"/>
+          </a:p>
+        </p:txBody>
+      </p:sp>
+      <p:sp>
+        <p:nvSpPr>
+          <p:cNvPr id="18" name="Text 16"/>
+          <p:cNvSpPr/>
+          <p:nvPr/>
+        </p:nvSpPr>
+        <p:spPr>
+          <a:xfrm>
+            <a:off x="8363560" y="2697480"/>
+            <a:ext cx="3108960" cy="365760"/>
+          </a:xfrm>
+          <a:prstGeom prst="rect">
+            <a:avLst/>
+          </a:prstGeom>
+          <a:noFill/>
+          <a:ln/>
+        </p:spPr>
+        <p:txBody>
+          <a:bodyPr wrap="square" lIns="0" tIns="0" rIns="0" bIns="0" rtlCol="0" anchor="ctr"/>
+          <a:lstStyle/>
+          <a:p>
+            <a:pPr marL="0" indent="0">
+              <a:buNone/>
+            </a:pPr>
+            <a:r>
+              <a:rPr lang="en-US" sz="1300" b="1" dirty="0">
+                <a:solidFill>
+                  <a:srgbClr val="0F172A"/>
+                </a:solidFill>
+                <a:latin typeface="Calibri" pitchFamily="34" charset="0"/>
+                <a:ea typeface="Calibri" pitchFamily="34" charset="-122"/>
+                <a:cs typeface="Calibri" pitchFamily="34" charset="-120"/>
+              </a:rPr>
+              <a:t>Word-boundary regex matching</a:t>
+            </a:r>
+            <a:endParaRPr lang="en-US" sz="1300" dirty="0"/>
+          </a:p>
+        </p:txBody>
+      </p:sp>
+      <p:sp>
+        <p:nvSpPr>
+          <p:cNvPr id="19" name="Text 17"/>
+          <p:cNvSpPr/>
+          <p:nvPr/>
+        </p:nvSpPr>
+        <p:spPr>
+          <a:xfrm>
+            <a:off x="8363560" y="3063240"/>
+            <a:ext cx="3108960" cy="777240"/>
+          </a:xfrm>
+          <a:prstGeom prst="rect">
+            <a:avLst/>
+          </a:prstGeom>
+          <a:noFill/>
+          <a:ln/>
+        </p:spPr>
+        <p:txBody>
+          <a:bodyPr wrap="square" lIns="0" tIns="0" rIns="0" bIns="0" rtlCol="0" anchor="ctr"/>
+          <a:lstStyle/>
+          <a:p>
+            <a:pPr marL="0" indent="0">
+              <a:buNone/>
+            </a:pPr>
+            <a:r>
+              <a:rPr lang="en-US" sz="1050" dirty="0">
+                <a:solidFill>
+                  <a:srgbClr val="1E293B"/>
+                </a:solidFill>
+                <a:latin typeface="Calibri" pitchFamily="34" charset="0"/>
+                <a:ea typeface="Calibri" pitchFamily="34" charset="-122"/>
+                <a:cs typeface="Calibri" pitchFamily="34" charset="-120"/>
+              </a:rPr>
+              <a:t>\</a:t>
+            </a:r>
+            <a:r>
+              <a:rPr lang="en-US" sz="1050" dirty="0" err="1">
+                <a:solidFill>
+                  <a:srgbClr val="1E293B"/>
+                </a:solidFill>
+                <a:latin typeface="Calibri" pitchFamily="34" charset="0"/>
+                <a:ea typeface="Calibri" pitchFamily="34" charset="-122"/>
+                <a:cs typeface="Calibri" pitchFamily="34" charset="-120"/>
+              </a:rPr>
+              <a:t>bukraine</a:t>
+            </a:r>
+            <a:r>
+              <a:rPr lang="en-US" sz="1050" dirty="0">
+                <a:solidFill>
+                  <a:srgbClr val="1E293B"/>
+                </a:solidFill>
+                <a:latin typeface="Calibri" pitchFamily="34" charset="0"/>
+                <a:ea typeface="Calibri" pitchFamily="34" charset="-122"/>
+                <a:cs typeface="Calibri" pitchFamily="34" charset="-120"/>
+              </a:rPr>
+              <a:t>\b avoids false positives like "ukrainian" or partial substring noise — fewer wasted page downloads.</a:t>
+            </a:r>
+            <a:endParaRPr lang="en-US" sz="1050" dirty="0"/>
+          </a:p>
+        </p:txBody>
+      </p:sp>
+      <p:sp>
+        <p:nvSpPr>
+          <p:cNvPr id="20" name="Shape 18"/>
+          <p:cNvSpPr/>
+          <p:nvPr/>
+        </p:nvSpPr>
+        <p:spPr>
+          <a:xfrm>
+            <a:off x="444856" y="4096512"/>
+            <a:ext cx="3657600" cy="1828800"/>
+          </a:xfrm>
+          <a:prstGeom prst="rect">
+            <a:avLst/>
+          </a:prstGeom>
+          <a:solidFill>
+            <a:srgbClr val="FFFFFF"/>
+          </a:solidFill>
+          <a:ln w="12700">
+            <a:solidFill>
+              <a:srgbClr val="E2E8F0"/>
+            </a:solidFill>
+            <a:prstDash val="solid"/>
+          </a:ln>
+          <a:effectLst>
+            <a:outerShdw blurRad="101600" dist="25400" dir="5400000" algn="bl" rotWithShape="0">
+              <a:srgbClr val="0F172A">
+                <a:alpha val="8000"/>
+              </a:srgbClr>
+            </a:outerShdw>
+          </a:effectLst>
+        </p:spPr>
+        <p:txBody>
+          <a:bodyPr/>
+          <a:lstStyle/>
+          <a:p>
+            <a:endParaRPr lang="en-US"/>
+          </a:p>
+        </p:txBody>
+      </p:sp>
+      <p:sp>
+        <p:nvSpPr>
+          <p:cNvPr id="21" name="Text 19"/>
+          <p:cNvSpPr/>
+          <p:nvPr/>
+        </p:nvSpPr>
+        <p:spPr>
+          <a:xfrm>
+            <a:off x="719176" y="4279392"/>
+            <a:ext cx="1371600" cy="457200"/>
+          </a:xfrm>
+          <a:prstGeom prst="rect">
+            <a:avLst/>
+          </a:prstGeom>
+          <a:noFill/>
+          <a:ln/>
+        </p:spPr>
+        <p:txBody>
+          <a:bodyPr wrap="square" lIns="0" tIns="0" rIns="0" bIns="0" rtlCol="0" anchor="ctr"/>
+          <a:lstStyle/>
+          <a:p>
+            <a:pPr marL="0" indent="0">
+              <a:buNone/>
+            </a:pPr>
+            <a:r>
+              <a:rPr lang="en-US" sz="2200" b="1" dirty="0">
+                <a:solidFill>
+                  <a:srgbClr val="14B8A6"/>
+                </a:solidFill>
+                <a:latin typeface="Georgia"/>
+              </a:rPr>
+              <a:t>04</a:t>
+            </a:r>
+            <a:endParaRPr lang="en-US" sz="2200">
+              <a:solidFill>
+                <a:srgbClr val="000000"/>
+              </a:solidFill>
+              <a:latin typeface="Calibri"/>
+              <a:ea typeface="Calibri"/>
+              <a:cs typeface="Calibri"/>
+            </a:endParaRPr>
+          </a:p>
+        </p:txBody>
+      </p:sp>
+      <p:sp>
+        <p:nvSpPr>
+          <p:cNvPr id="22" name="Text 20"/>
+          <p:cNvSpPr/>
+          <p:nvPr/>
+        </p:nvSpPr>
+        <p:spPr>
+          <a:xfrm>
+            <a:off x="719176" y="4690872"/>
+            <a:ext cx="3108960" cy="365760"/>
+          </a:xfrm>
+          <a:prstGeom prst="rect">
+            <a:avLst/>
+          </a:prstGeom>
+          <a:noFill/>
+          <a:ln/>
+        </p:spPr>
+        <p:txBody>
+          <a:bodyPr wrap="square" lIns="0" tIns="0" rIns="0" bIns="0" rtlCol="0" anchor="ctr"/>
+          <a:lstStyle/>
+          <a:p>
+            <a:pPr marL="0" indent="0">
+              <a:buNone/>
+            </a:pPr>
+            <a:r>
+              <a:rPr lang="en-US" sz="1300" b="1" dirty="0">
+                <a:solidFill>
+                  <a:srgbClr val="0F172A"/>
+                </a:solidFill>
+                <a:latin typeface="Calibri" pitchFamily="34" charset="0"/>
+                <a:ea typeface="Calibri" pitchFamily="34" charset="-122"/>
+                <a:cs typeface="Calibri" pitchFamily="34" charset="-120"/>
+              </a:rPr>
+              <a:t>Persisted XML cache</a:t>
+            </a:r>
+            <a:endParaRPr lang="en-US" sz="1300" dirty="0"/>
+          </a:p>
+        </p:txBody>
+      </p:sp>
+      <p:sp>
+        <p:nvSpPr>
+          <p:cNvPr id="23" name="Text 21"/>
+          <p:cNvSpPr/>
+          <p:nvPr/>
+        </p:nvSpPr>
+        <p:spPr>
+          <a:xfrm>
+            <a:off x="719176" y="5056632"/>
+            <a:ext cx="3108960" cy="777240"/>
+          </a:xfrm>
+          <a:prstGeom prst="rect">
+            <a:avLst/>
+          </a:prstGeom>
+          <a:noFill/>
+          <a:ln/>
+        </p:spPr>
+        <p:txBody>
+          <a:bodyPr wrap="square" lIns="0" tIns="0" rIns="0" bIns="0" rtlCol="0" anchor="ctr"/>
+          <a:lstStyle/>
+          <a:p>
+            <a:pPr marL="0" indent="0">
+              <a:buNone/>
+            </a:pPr>
+            <a:r>
+              <a:rPr lang="en-US" sz="1050" dirty="0">
+                <a:solidFill>
+                  <a:srgbClr val="1E293B"/>
+                </a:solidFill>
+                <a:latin typeface="Calibri"/>
+                <a:ea typeface="Calibri"/>
+                <a:cs typeface="Calibri"/>
+              </a:rPr>
+              <a:t>Sitemaps are written to /_pages/&lt;topic&gt;/. </a:t>
+            </a:r>
+          </a:p>
+        </p:txBody>
+      </p:sp>
+      <p:sp>
+        <p:nvSpPr>
+          <p:cNvPr id="24" name="Shape 22"/>
+          <p:cNvSpPr/>
+          <p:nvPr/>
+        </p:nvSpPr>
+        <p:spPr>
+          <a:xfrm>
+            <a:off x="4267048" y="4096512"/>
+            <a:ext cx="3657600" cy="1828800"/>
+          </a:xfrm>
+          <a:prstGeom prst="rect">
+            <a:avLst/>
+          </a:prstGeom>
+          <a:solidFill>
+            <a:srgbClr val="FFFFFF"/>
+          </a:solidFill>
+          <a:ln w="12700">
+            <a:solidFill>
+              <a:srgbClr val="E2E8F0"/>
+            </a:solidFill>
+            <a:prstDash val="solid"/>
+          </a:ln>
+          <a:effectLst>
+            <a:outerShdw blurRad="101600" dist="25400" dir="5400000" algn="bl" rotWithShape="0">
+              <a:srgbClr val="0F172A">
+                <a:alpha val="8000"/>
+              </a:srgbClr>
+            </a:outerShdw>
+          </a:effectLst>
+        </p:spPr>
+        <p:txBody>
+          <a:bodyPr/>
+          <a:lstStyle/>
+          <a:p>
+            <a:endParaRPr lang="en-US"/>
+          </a:p>
+        </p:txBody>
+      </p:sp>
+      <p:sp>
+        <p:nvSpPr>
+          <p:cNvPr id="25" name="Text 23"/>
+          <p:cNvSpPr/>
+          <p:nvPr/>
+        </p:nvSpPr>
+        <p:spPr>
+          <a:xfrm>
+            <a:off x="4541368" y="4279392"/>
+            <a:ext cx="1371600" cy="457200"/>
+          </a:xfrm>
+          <a:prstGeom prst="rect">
+            <a:avLst/>
+          </a:prstGeom>
+          <a:noFill/>
+          <a:ln/>
+        </p:spPr>
+        <p:txBody>
+          <a:bodyPr wrap="square" lIns="0" tIns="0" rIns="0" bIns="0" rtlCol="0" anchor="ctr"/>
+          <a:lstStyle/>
+          <a:p>
+            <a:pPr marL="0" indent="0">
+              <a:buNone/>
+            </a:pPr>
+            <a:r>
+              <a:rPr lang="en-US" sz="2200" b="1" dirty="0">
+                <a:solidFill>
+                  <a:srgbClr val="14B8A6"/>
+                </a:solidFill>
+                <a:latin typeface="Georgia" pitchFamily="34" charset="0"/>
+                <a:ea typeface="Georgia" pitchFamily="34" charset="-122"/>
+                <a:cs typeface="Georgia" pitchFamily="34" charset="-120"/>
+              </a:rPr>
+              <a:t>05</a:t>
+            </a:r>
+            <a:endParaRPr lang="en-US" sz="2200" dirty="0"/>
+          </a:p>
+        </p:txBody>
+      </p:sp>
+      <p:sp>
+        <p:nvSpPr>
+          <p:cNvPr id="26" name="Text 24"/>
+          <p:cNvSpPr/>
+          <p:nvPr/>
+        </p:nvSpPr>
+        <p:spPr>
+          <a:xfrm>
+            <a:off x="4541368" y="4690872"/>
+            <a:ext cx="3108960" cy="365760"/>
+          </a:xfrm>
+          <a:prstGeom prst="rect">
+            <a:avLst/>
+          </a:prstGeom>
+          <a:noFill/>
+          <a:ln/>
+        </p:spPr>
+        <p:txBody>
+          <a:bodyPr wrap="square" lIns="0" tIns="0" rIns="0" bIns="0" rtlCol="0" anchor="ctr"/>
+          <a:lstStyle/>
+          <a:p>
+            <a:pPr marL="0" indent="0">
+              <a:buNone/>
+            </a:pPr>
+            <a:r>
+              <a:rPr lang="en-US" sz="1300" b="1" dirty="0">
+                <a:solidFill>
+                  <a:srgbClr val="0F172A"/>
+                </a:solidFill>
+                <a:latin typeface="Calibri" pitchFamily="34" charset="0"/>
+                <a:ea typeface="Calibri" pitchFamily="34" charset="-122"/>
+                <a:cs typeface="Calibri" pitchFamily="34" charset="-120"/>
+              </a:rPr>
+              <a:t>Streamed file writes</a:t>
+            </a:r>
+            <a:endParaRPr lang="en-US" sz="1300" dirty="0"/>
+          </a:p>
+        </p:txBody>
+      </p:sp>
+      <p:sp>
+        <p:nvSpPr>
+          <p:cNvPr id="27" name="Text 25"/>
+          <p:cNvSpPr/>
+          <p:nvPr/>
+        </p:nvSpPr>
+        <p:spPr>
+          <a:xfrm>
+            <a:off x="4541368" y="5056632"/>
+            <a:ext cx="3108960" cy="777240"/>
+          </a:xfrm>
+          <a:prstGeom prst="rect">
+            <a:avLst/>
+          </a:prstGeom>
+          <a:noFill/>
+          <a:ln/>
+        </p:spPr>
+        <p:txBody>
+          <a:bodyPr wrap="square" lIns="0" tIns="0" rIns="0" bIns="0" rtlCol="0" anchor="ctr"/>
+          <a:lstStyle/>
+          <a:p>
+            <a:pPr marL="0" indent="0">
+              <a:buNone/>
+            </a:pPr>
+            <a:r>
+              <a:rPr lang="en-US" sz="1050" dirty="0">
+                <a:solidFill>
+                  <a:srgbClr val="1E293B"/>
+                </a:solidFill>
+                <a:latin typeface="Calibri" pitchFamily="34" charset="0"/>
+                <a:ea typeface="Calibri" pitchFamily="34" charset="-122"/>
+                <a:cs typeface="Calibri" pitchFamily="34" charset="-120"/>
+              </a:rPr>
+              <a:t>Open / write / close per file; HTML never accumulates in memory across the run.</a:t>
+            </a:r>
+            <a:endParaRPr lang="en-US" sz="1050" dirty="0"/>
+          </a:p>
+        </p:txBody>
+      </p:sp>
+      <p:sp>
+        <p:nvSpPr>
+          <p:cNvPr id="28" name="Shape 26"/>
+          <p:cNvSpPr/>
+          <p:nvPr/>
+        </p:nvSpPr>
+        <p:spPr>
+          <a:xfrm>
+            <a:off x="8089240" y="4096512"/>
+            <a:ext cx="3657600" cy="1828800"/>
+          </a:xfrm>
+          <a:prstGeom prst="rect">
+            <a:avLst/>
+          </a:prstGeom>
+          <a:solidFill>
+            <a:srgbClr val="FFFFFF"/>
+          </a:solidFill>
+          <a:ln w="12700">
+            <a:solidFill>
+              <a:srgbClr val="E2E8F0"/>
+            </a:solidFill>
+            <a:prstDash val="solid"/>
+          </a:ln>
+          <a:effectLst>
+            <a:outerShdw blurRad="101600" dist="25400" dir="5400000" algn="bl" rotWithShape="0">
+              <a:srgbClr val="0F172A">
+                <a:alpha val="8000"/>
+              </a:srgbClr>
+            </a:outerShdw>
+          </a:effectLst>
+        </p:spPr>
+        <p:txBody>
+          <a:bodyPr/>
+          <a:lstStyle/>
+          <a:p>
+            <a:endParaRPr lang="en-US"/>
+          </a:p>
+        </p:txBody>
+      </p:sp>
+      <p:sp>
+        <p:nvSpPr>
+          <p:cNvPr id="29" name="Text 27"/>
+          <p:cNvSpPr/>
+          <p:nvPr/>
+        </p:nvSpPr>
+        <p:spPr>
+          <a:xfrm>
+            <a:off x="8363560" y="4279392"/>
+            <a:ext cx="1371600" cy="457200"/>
+          </a:xfrm>
+          <a:prstGeom prst="rect">
+            <a:avLst/>
+          </a:prstGeom>
+          <a:noFill/>
+          <a:ln/>
+        </p:spPr>
+        <p:txBody>
+          <a:bodyPr wrap="square" lIns="0" tIns="0" rIns="0" bIns="0" rtlCol="0" anchor="ctr"/>
+          <a:lstStyle/>
+          <a:p>
+            <a:pPr marL="0" indent="0">
+              <a:buNone/>
+            </a:pPr>
+            <a:r>
+              <a:rPr lang="en-US" sz="2200" b="1" dirty="0">
+                <a:solidFill>
+                  <a:srgbClr val="14B8A6"/>
+                </a:solidFill>
+                <a:latin typeface="Georgia" pitchFamily="34" charset="0"/>
+                <a:ea typeface="Georgia" pitchFamily="34" charset="-122"/>
+                <a:cs typeface="Georgia" pitchFamily="34" charset="-120"/>
+              </a:rPr>
+              <a:t>06</a:t>
+            </a:r>
+            <a:endParaRPr lang="en-US" sz="2200" dirty="0"/>
+          </a:p>
+        </p:txBody>
+      </p:sp>
+      <p:sp>
+        <p:nvSpPr>
+          <p:cNvPr id="30" name="Text 28"/>
+          <p:cNvSpPr/>
+          <p:nvPr/>
+        </p:nvSpPr>
+        <p:spPr>
+          <a:xfrm>
+            <a:off x="8363560" y="4690872"/>
+            <a:ext cx="3108960" cy="365760"/>
+          </a:xfrm>
+          <a:prstGeom prst="rect">
+            <a:avLst/>
+          </a:prstGeom>
+          <a:noFill/>
+          <a:ln/>
+        </p:spPr>
+        <p:txBody>
+          <a:bodyPr wrap="square" lIns="0" tIns="0" rIns="0" bIns="0" rtlCol="0" anchor="ctr"/>
+          <a:lstStyle/>
+          <a:p>
+            <a:pPr marL="0" indent="0">
+              <a:buNone/>
+            </a:pPr>
+            <a:r>
+              <a:rPr lang="en-US" sz="1300" b="1" dirty="0">
+                <a:solidFill>
+                  <a:srgbClr val="0F172A"/>
+                </a:solidFill>
+                <a:latin typeface="Calibri" pitchFamily="34" charset="0"/>
+                <a:ea typeface="Calibri" pitchFamily="34" charset="-122"/>
+                <a:cs typeface="Calibri" pitchFamily="34" charset="-120"/>
+              </a:rPr>
+              <a:t>Single-purpose pipeline</a:t>
+            </a:r>
+            <a:endParaRPr lang="en-US" sz="1300" dirty="0"/>
+          </a:p>
+        </p:txBody>
+      </p:sp>
+      <p:sp>
+        <p:nvSpPr>
+          <p:cNvPr id="31" name="Text 29"/>
+          <p:cNvSpPr/>
+          <p:nvPr/>
+        </p:nvSpPr>
+        <p:spPr>
+          <a:xfrm>
+            <a:off x="8363560" y="5056632"/>
+            <a:ext cx="3108960" cy="777240"/>
+          </a:xfrm>
+          <a:prstGeom prst="rect">
+            <a:avLst/>
+          </a:prstGeom>
+          <a:noFill/>
+          <a:ln/>
+        </p:spPr>
+        <p:txBody>
+          <a:bodyPr wrap="square" lIns="0" tIns="0" rIns="0" bIns="0" rtlCol="0" anchor="ctr"/>
+          <a:lstStyle/>
+          <a:p>
+            <a:pPr marL="0" indent="0">
+              <a:buNone/>
+            </a:pPr>
+            <a:r>
+              <a:rPr lang="en-US" sz="1050" dirty="0">
+                <a:solidFill>
+                  <a:srgbClr val="1E293B"/>
+                </a:solidFill>
+                <a:latin typeface="Calibri" pitchFamily="34" charset="0"/>
+                <a:ea typeface="Calibri" pitchFamily="34" charset="-122"/>
+                <a:cs typeface="Calibri" pitchFamily="34" charset="-120"/>
+              </a:rPr>
+              <a:t>parse → store → download. Each stage is independent and re-runnable on its own outputs.</a:t>
+            </a:r>
+            <a:endParaRPr lang="en-US" sz="1050" dirty="0"/>
           </a:p>
         </p:txBody>
       </p:sp>

</xml_diff>